<commit_message>
update sphinx rst files
</commit_message>
<xml_diff>
--- a/docs/figs/blog_figures.pptx
+++ b/docs/figs/blog_figures.pptx
@@ -8,6 +8,7 @@
     <p:sldId id="258" r:id="rId2"/>
     <p:sldId id="257" r:id="rId3"/>
     <p:sldId id="259" r:id="rId4"/>
+    <p:sldId id="260" r:id="rId5"/>
   </p:sldIdLst>
   <p:sldSz cx="12192000" cy="6858000"/>
   <p:notesSz cx="6858000" cy="9144000"/>
@@ -263,7 +264,7 @@
           <a:p>
             <a:fld id="{922860D0-EBC9-4CCD-82FB-90EB89E22FA7}" type="datetimeFigureOut">
               <a:rPr lang="en-NL" smtClean="0"/>
-              <a:t>13/09/2025</a:t>
+              <a:t>21/09/2025</a:t>
             </a:fld>
             <a:endParaRPr lang="en-NL"/>
           </a:p>
@@ -463,7 +464,7 @@
           <a:p>
             <a:fld id="{922860D0-EBC9-4CCD-82FB-90EB89E22FA7}" type="datetimeFigureOut">
               <a:rPr lang="en-NL" smtClean="0"/>
-              <a:t>13/09/2025</a:t>
+              <a:t>21/09/2025</a:t>
             </a:fld>
             <a:endParaRPr lang="en-NL"/>
           </a:p>
@@ -673,7 +674,7 @@
           <a:p>
             <a:fld id="{922860D0-EBC9-4CCD-82FB-90EB89E22FA7}" type="datetimeFigureOut">
               <a:rPr lang="en-NL" smtClean="0"/>
-              <a:t>13/09/2025</a:t>
+              <a:t>21/09/2025</a:t>
             </a:fld>
             <a:endParaRPr lang="en-NL"/>
           </a:p>
@@ -873,7 +874,7 @@
           <a:p>
             <a:fld id="{922860D0-EBC9-4CCD-82FB-90EB89E22FA7}" type="datetimeFigureOut">
               <a:rPr lang="en-NL" smtClean="0"/>
-              <a:t>13/09/2025</a:t>
+              <a:t>21/09/2025</a:t>
             </a:fld>
             <a:endParaRPr lang="en-NL"/>
           </a:p>
@@ -1149,7 +1150,7 @@
           <a:p>
             <a:fld id="{922860D0-EBC9-4CCD-82FB-90EB89E22FA7}" type="datetimeFigureOut">
               <a:rPr lang="en-NL" smtClean="0"/>
-              <a:t>13/09/2025</a:t>
+              <a:t>21/09/2025</a:t>
             </a:fld>
             <a:endParaRPr lang="en-NL"/>
           </a:p>
@@ -1417,7 +1418,7 @@
           <a:p>
             <a:fld id="{922860D0-EBC9-4CCD-82FB-90EB89E22FA7}" type="datetimeFigureOut">
               <a:rPr lang="en-NL" smtClean="0"/>
-              <a:t>13/09/2025</a:t>
+              <a:t>21/09/2025</a:t>
             </a:fld>
             <a:endParaRPr lang="en-NL"/>
           </a:p>
@@ -1832,7 +1833,7 @@
           <a:p>
             <a:fld id="{922860D0-EBC9-4CCD-82FB-90EB89E22FA7}" type="datetimeFigureOut">
               <a:rPr lang="en-NL" smtClean="0"/>
-              <a:t>13/09/2025</a:t>
+              <a:t>21/09/2025</a:t>
             </a:fld>
             <a:endParaRPr lang="en-NL"/>
           </a:p>
@@ -1974,7 +1975,7 @@
           <a:p>
             <a:fld id="{922860D0-EBC9-4CCD-82FB-90EB89E22FA7}" type="datetimeFigureOut">
               <a:rPr lang="en-NL" smtClean="0"/>
-              <a:t>13/09/2025</a:t>
+              <a:t>21/09/2025</a:t>
             </a:fld>
             <a:endParaRPr lang="en-NL"/>
           </a:p>
@@ -2087,7 +2088,7 @@
           <a:p>
             <a:fld id="{922860D0-EBC9-4CCD-82FB-90EB89E22FA7}" type="datetimeFigureOut">
               <a:rPr lang="en-NL" smtClean="0"/>
-              <a:t>13/09/2025</a:t>
+              <a:t>21/09/2025</a:t>
             </a:fld>
             <a:endParaRPr lang="en-NL"/>
           </a:p>
@@ -2400,7 +2401,7 @@
           <a:p>
             <a:fld id="{922860D0-EBC9-4CCD-82FB-90EB89E22FA7}" type="datetimeFigureOut">
               <a:rPr lang="en-NL" smtClean="0"/>
-              <a:t>13/09/2025</a:t>
+              <a:t>21/09/2025</a:t>
             </a:fld>
             <a:endParaRPr lang="en-NL"/>
           </a:p>
@@ -2689,7 +2690,7 @@
           <a:p>
             <a:fld id="{922860D0-EBC9-4CCD-82FB-90EB89E22FA7}" type="datetimeFigureOut">
               <a:rPr lang="en-NL" smtClean="0"/>
-              <a:t>13/09/2025</a:t>
+              <a:t>21/09/2025</a:t>
             </a:fld>
             <a:endParaRPr lang="en-NL"/>
           </a:p>
@@ -2932,7 +2933,7 @@
           <a:p>
             <a:fld id="{922860D0-EBC9-4CCD-82FB-90EB89E22FA7}" type="datetimeFigureOut">
               <a:rPr lang="en-NL" smtClean="0"/>
-              <a:t>13/09/2025</a:t>
+              <a:t>21/09/2025</a:t>
             </a:fld>
             <a:endParaRPr lang="en-NL"/>
           </a:p>
@@ -10074,6 +10075,2736 @@
 </p:sld>
 </file>
 
+<file path=ppt/slides/slide4.xml><?xml version="1.0" encoding="utf-8"?>
+<p:sld xmlns:a="http://schemas.openxmlformats.org/drawingml/2006/main" xmlns:r="http://schemas.openxmlformats.org/officeDocument/2006/relationships" xmlns:p="http://schemas.openxmlformats.org/presentationml/2006/main">
+  <p:cSld>
+    <p:spTree>
+      <p:nvGrpSpPr>
+        <p:cNvPr id="1" name="">
+          <a:extLst>
+            <a:ext uri="{FF2B5EF4-FFF2-40B4-BE49-F238E27FC236}">
+              <a16:creationId xmlns:a16="http://schemas.microsoft.com/office/drawing/2014/main" id="{7FE1AAAE-948B-697F-3DE9-4D51D28F020C}"/>
+            </a:ext>
+          </a:extLst>
+        </p:cNvPr>
+        <p:cNvGrpSpPr/>
+        <p:nvPr/>
+      </p:nvGrpSpPr>
+      <p:grpSpPr>
+        <a:xfrm>
+          <a:off x="0" y="0"/>
+          <a:ext cx="0" cy="0"/>
+          <a:chOff x="0" y="0"/>
+          <a:chExt cx="0" cy="0"/>
+        </a:xfrm>
+      </p:grpSpPr>
+      <p:sp>
+        <p:nvSpPr>
+          <p:cNvPr id="160" name="Rectangle 159">
+            <a:extLst>
+              <a:ext uri="{FF2B5EF4-FFF2-40B4-BE49-F238E27FC236}">
+                <a16:creationId xmlns:a16="http://schemas.microsoft.com/office/drawing/2014/main" id="{58840E08-2444-C545-ABFE-F1198A9D9204}"/>
+              </a:ext>
+            </a:extLst>
+          </p:cNvPr>
+          <p:cNvSpPr/>
+          <p:nvPr/>
+        </p:nvSpPr>
+        <p:spPr>
+          <a:xfrm>
+            <a:off x="7023535" y="3333483"/>
+            <a:ext cx="774646" cy="918766"/>
+          </a:xfrm>
+          <a:prstGeom prst="rect">
+            <a:avLst/>
+          </a:prstGeom>
+          <a:solidFill>
+            <a:sysClr val="window" lastClr="FFFFFF"/>
+          </a:solidFill>
+          <a:ln w="12700" cap="flat" cmpd="sng" algn="ctr">
+            <a:solidFill>
+              <a:srgbClr val="C4232A">
+                <a:lumMod val="60000"/>
+                <a:lumOff val="40000"/>
+              </a:srgbClr>
+            </a:solidFill>
+            <a:prstDash val="dash"/>
+            <a:miter lim="800000"/>
+          </a:ln>
+          <a:effectLst/>
+        </p:spPr>
+        <p:txBody>
+          <a:bodyPr rtlCol="0" anchor="ctr"/>
+          <a:lstStyle/>
+          <a:p>
+            <a:pPr marL="0" marR="0" lvl="0" indent="0" algn="ctr" defTabSz="914400" eaLnBrk="1" fontAlgn="auto" latinLnBrk="0" hangingPunct="1">
+              <a:lnSpc>
+                <a:spcPct val="100000"/>
+              </a:lnSpc>
+              <a:spcBef>
+                <a:spcPts val="0"/>
+              </a:spcBef>
+              <a:spcAft>
+                <a:spcPts val="0"/>
+              </a:spcAft>
+              <a:buClrTx/>
+              <a:buSzTx/>
+              <a:buFontTx/>
+              <a:buNone/>
+              <a:tabLst/>
+              <a:defRPr/>
+            </a:pPr>
+            <a:endParaRPr kumimoji="0" lang="nl-NL" sz="1800" b="0" i="0" u="none" strike="noStrike" kern="0" cap="none" spc="0" normalizeH="0" baseline="0" noProof="0">
+              <a:ln>
+                <a:noFill/>
+              </a:ln>
+              <a:solidFill>
+                <a:prstClr val="white"/>
+              </a:solidFill>
+              <a:effectLst/>
+              <a:uLnTx/>
+              <a:uFillTx/>
+              <a:latin typeface="Segoe UI Light"/>
+              <a:ea typeface="+mn-ea"/>
+              <a:cs typeface="+mn-cs"/>
+            </a:endParaRPr>
+          </a:p>
+        </p:txBody>
+      </p:sp>
+      <p:sp>
+        <p:nvSpPr>
+          <p:cNvPr id="82" name="Rectangle 81">
+            <a:extLst>
+              <a:ext uri="{FF2B5EF4-FFF2-40B4-BE49-F238E27FC236}">
+                <a16:creationId xmlns:a16="http://schemas.microsoft.com/office/drawing/2014/main" id="{D7284B7F-74B3-C07A-A47C-5576E441D90E}"/>
+              </a:ext>
+            </a:extLst>
+          </p:cNvPr>
+          <p:cNvSpPr/>
+          <p:nvPr/>
+        </p:nvSpPr>
+        <p:spPr>
+          <a:xfrm>
+            <a:off x="5646957" y="3342706"/>
+            <a:ext cx="774646" cy="918766"/>
+          </a:xfrm>
+          <a:prstGeom prst="rect">
+            <a:avLst/>
+          </a:prstGeom>
+          <a:solidFill>
+            <a:sysClr val="window" lastClr="FFFFFF"/>
+          </a:solidFill>
+          <a:ln w="12700" cap="flat" cmpd="sng" algn="ctr">
+            <a:solidFill>
+              <a:srgbClr val="C4232A">
+                <a:lumMod val="60000"/>
+                <a:lumOff val="40000"/>
+              </a:srgbClr>
+            </a:solidFill>
+            <a:prstDash val="dash"/>
+            <a:miter lim="800000"/>
+          </a:ln>
+          <a:effectLst/>
+        </p:spPr>
+        <p:txBody>
+          <a:bodyPr rtlCol="0" anchor="ctr"/>
+          <a:lstStyle/>
+          <a:p>
+            <a:pPr marL="0" marR="0" lvl="0" indent="0" algn="ctr" defTabSz="914400" eaLnBrk="1" fontAlgn="auto" latinLnBrk="0" hangingPunct="1">
+              <a:lnSpc>
+                <a:spcPct val="100000"/>
+              </a:lnSpc>
+              <a:spcBef>
+                <a:spcPts val="0"/>
+              </a:spcBef>
+              <a:spcAft>
+                <a:spcPts val="0"/>
+              </a:spcAft>
+              <a:buClrTx/>
+              <a:buSzTx/>
+              <a:buFontTx/>
+              <a:buNone/>
+              <a:tabLst/>
+              <a:defRPr/>
+            </a:pPr>
+            <a:endParaRPr kumimoji="0" lang="nl-NL" sz="1800" b="0" i="0" u="none" strike="noStrike" kern="0" cap="none" spc="0" normalizeH="0" baseline="0" noProof="0">
+              <a:ln>
+                <a:noFill/>
+              </a:ln>
+              <a:solidFill>
+                <a:prstClr val="white"/>
+              </a:solidFill>
+              <a:effectLst/>
+              <a:uLnTx/>
+              <a:uFillTx/>
+              <a:latin typeface="Segoe UI Light"/>
+              <a:ea typeface="+mn-ea"/>
+              <a:cs typeface="+mn-cs"/>
+            </a:endParaRPr>
+          </a:p>
+        </p:txBody>
+      </p:sp>
+      <p:grpSp>
+        <p:nvGrpSpPr>
+          <p:cNvPr id="83" name="Group 82">
+            <a:extLst>
+              <a:ext uri="{FF2B5EF4-FFF2-40B4-BE49-F238E27FC236}">
+                <a16:creationId xmlns:a16="http://schemas.microsoft.com/office/drawing/2014/main" id="{AFA73960-A823-9D36-5A0F-58D530C16498}"/>
+              </a:ext>
+            </a:extLst>
+          </p:cNvPr>
+          <p:cNvGrpSpPr/>
+          <p:nvPr/>
+        </p:nvGrpSpPr>
+        <p:grpSpPr>
+          <a:xfrm>
+            <a:off x="1986266" y="3118647"/>
+            <a:ext cx="2211423" cy="1242027"/>
+            <a:chOff x="2269137" y="4929447"/>
+            <a:chExt cx="2211423" cy="1242027"/>
+          </a:xfrm>
+        </p:grpSpPr>
+        <p:sp>
+          <p:nvSpPr>
+            <p:cNvPr id="84" name="Cylinder 83">
+              <a:extLst>
+                <a:ext uri="{FF2B5EF4-FFF2-40B4-BE49-F238E27FC236}">
+                  <a16:creationId xmlns:a16="http://schemas.microsoft.com/office/drawing/2014/main" id="{A94A7FA4-7198-2B7D-D285-51ACDF9FC726}"/>
+                </a:ext>
+              </a:extLst>
+            </p:cNvPr>
+            <p:cNvSpPr/>
+            <p:nvPr/>
+          </p:nvSpPr>
+          <p:spPr>
+            <a:xfrm>
+              <a:off x="3596386" y="5070506"/>
+              <a:ext cx="673582" cy="841319"/>
+            </a:xfrm>
+            <a:prstGeom prst="can">
+              <a:avLst/>
+            </a:prstGeom>
+            <a:solidFill>
+              <a:sysClr val="window" lastClr="FFFFFF"/>
+            </a:solidFill>
+            <a:ln w="12700" cap="flat" cmpd="sng" algn="ctr">
+              <a:solidFill>
+                <a:sysClr val="windowText" lastClr="000000"/>
+              </a:solidFill>
+              <a:prstDash val="solid"/>
+              <a:miter lim="800000"/>
+            </a:ln>
+            <a:effectLst/>
+          </p:spPr>
+          <p:txBody>
+            <a:bodyPr rtlCol="0" anchor="ctr"/>
+            <a:lstStyle/>
+            <a:p>
+              <a:pPr marL="0" marR="0" lvl="0" indent="0" algn="ctr" defTabSz="914400" eaLnBrk="1" fontAlgn="auto" latinLnBrk="0" hangingPunct="1">
+                <a:lnSpc>
+                  <a:spcPct val="100000"/>
+                </a:lnSpc>
+                <a:spcBef>
+                  <a:spcPts val="0"/>
+                </a:spcBef>
+                <a:spcAft>
+                  <a:spcPts val="0"/>
+                </a:spcAft>
+                <a:buClrTx/>
+                <a:buSzTx/>
+                <a:buFontTx/>
+                <a:buNone/>
+                <a:tabLst/>
+                <a:defRPr/>
+              </a:pPr>
+              <a:endParaRPr kumimoji="0" lang="nl-NL" sz="1800" b="0" i="0" u="none" strike="noStrike" kern="0" cap="none" spc="0" normalizeH="0" baseline="0" noProof="0">
+                <a:ln>
+                  <a:noFill/>
+                </a:ln>
+                <a:solidFill>
+                  <a:prstClr val="white"/>
+                </a:solidFill>
+                <a:effectLst/>
+                <a:uLnTx/>
+                <a:uFillTx/>
+                <a:latin typeface="Segoe UI Light"/>
+                <a:ea typeface="+mn-ea"/>
+                <a:cs typeface="+mn-cs"/>
+              </a:endParaRPr>
+            </a:p>
+          </p:txBody>
+        </p:sp>
+        <p:sp>
+          <p:nvSpPr>
+            <p:cNvPr id="85" name="TextBox 84">
+              <a:extLst>
+                <a:ext uri="{FF2B5EF4-FFF2-40B4-BE49-F238E27FC236}">
+                  <a16:creationId xmlns:a16="http://schemas.microsoft.com/office/drawing/2014/main" id="{43D8B686-9B69-7335-BE66-986BFE348E30}"/>
+                </a:ext>
+              </a:extLst>
+            </p:cNvPr>
+            <p:cNvSpPr txBox="1"/>
+            <p:nvPr/>
+          </p:nvSpPr>
+          <p:spPr>
+            <a:xfrm>
+              <a:off x="3561592" y="5345092"/>
+              <a:ext cx="726481" cy="272062"/>
+            </a:xfrm>
+            <a:prstGeom prst="rect">
+              <a:avLst/>
+            </a:prstGeom>
+            <a:noFill/>
+          </p:spPr>
+          <p:txBody>
+            <a:bodyPr wrap="none" rtlCol="0">
+              <a:spAutoFit/>
+            </a:bodyPr>
+            <a:lstStyle/>
+            <a:p>
+              <a:pPr marL="0" marR="0" lvl="0" indent="0" algn="ctr" defTabSz="914400" eaLnBrk="1" fontAlgn="auto" latinLnBrk="0" hangingPunct="1">
+                <a:lnSpc>
+                  <a:spcPct val="150000"/>
+                </a:lnSpc>
+                <a:spcBef>
+                  <a:spcPts val="0"/>
+                </a:spcBef>
+                <a:spcAft>
+                  <a:spcPts val="0"/>
+                </a:spcAft>
+                <a:buClrTx/>
+                <a:buSzTx/>
+                <a:buFontTx/>
+                <a:buNone/>
+                <a:tabLst/>
+                <a:defRPr/>
+              </a:pPr>
+              <a:r>
+                <a:rPr kumimoji="0" lang="en-US" sz="900" b="0" i="0" u="none" strike="noStrike" kern="0" cap="none" spc="0" normalizeH="0" baseline="0" noProof="0" dirty="0">
+                  <a:ln>
+                    <a:noFill/>
+                  </a:ln>
+                  <a:solidFill>
+                    <a:prstClr val="black"/>
+                  </a:solidFill>
+                  <a:effectLst/>
+                  <a:uLnTx/>
+                  <a:uFillTx/>
+                  <a:latin typeface="Verdana" panose="020B0604030504040204" pitchFamily="34" charset="0"/>
+                  <a:ea typeface="Verdana" panose="020B0604030504040204" pitchFamily="34" charset="0"/>
+                </a:rPr>
+                <a:t>Database</a:t>
+              </a:r>
+            </a:p>
+          </p:txBody>
+        </p:sp>
+        <p:sp>
+          <p:nvSpPr>
+            <p:cNvPr id="88" name="TextBox 87">
+              <a:extLst>
+                <a:ext uri="{FF2B5EF4-FFF2-40B4-BE49-F238E27FC236}">
+                  <a16:creationId xmlns:a16="http://schemas.microsoft.com/office/drawing/2014/main" id="{E5EA8912-E7D9-21D5-9A82-60EBF667D82C}"/>
+                </a:ext>
+              </a:extLst>
+            </p:cNvPr>
+            <p:cNvSpPr txBox="1"/>
+            <p:nvPr/>
+          </p:nvSpPr>
+          <p:spPr>
+            <a:xfrm>
+              <a:off x="2787015" y="5262879"/>
+              <a:ext cx="673582" cy="461665"/>
+            </a:xfrm>
+            <a:prstGeom prst="rect">
+              <a:avLst/>
+            </a:prstGeom>
+            <a:noFill/>
+          </p:spPr>
+          <p:txBody>
+            <a:bodyPr wrap="none" rtlCol="0">
+              <a:spAutoFit/>
+            </a:bodyPr>
+            <a:lstStyle/>
+            <a:p>
+              <a:pPr marL="0" marR="0" lvl="0" indent="0" algn="ctr" defTabSz="914400" eaLnBrk="1" fontAlgn="auto" latinLnBrk="0" hangingPunct="1">
+                <a:lnSpc>
+                  <a:spcPct val="100000"/>
+                </a:lnSpc>
+                <a:spcBef>
+                  <a:spcPts val="0"/>
+                </a:spcBef>
+                <a:spcAft>
+                  <a:spcPts val="0"/>
+                </a:spcAft>
+                <a:buClrTx/>
+                <a:buSzTx/>
+                <a:buFontTx/>
+                <a:buNone/>
+                <a:tabLst/>
+                <a:defRPr/>
+              </a:pPr>
+              <a:r>
+                <a:rPr kumimoji="0" lang="en-US" sz="800" b="0" i="0" u="none" strike="noStrike" kern="0" cap="none" spc="0" normalizeH="0" baseline="0" noProof="0" dirty="0">
+                  <a:ln>
+                    <a:noFill/>
+                  </a:ln>
+                  <a:solidFill>
+                    <a:prstClr val="black"/>
+                  </a:solidFill>
+                  <a:effectLst/>
+                  <a:uLnTx/>
+                  <a:uFillTx/>
+                  <a:latin typeface="Verdana" panose="020B0604030504040204" pitchFamily="34" charset="0"/>
+                  <a:ea typeface="Verdana" panose="020B0604030504040204" pitchFamily="34" charset="0"/>
+                </a:rPr>
+                <a:t>Chunking</a:t>
+              </a:r>
+            </a:p>
+            <a:p>
+              <a:pPr marL="0" marR="0" lvl="0" indent="0" algn="ctr" defTabSz="914400" eaLnBrk="1" fontAlgn="auto" latinLnBrk="0" hangingPunct="1">
+                <a:lnSpc>
+                  <a:spcPct val="100000"/>
+                </a:lnSpc>
+                <a:spcBef>
+                  <a:spcPts val="0"/>
+                </a:spcBef>
+                <a:spcAft>
+                  <a:spcPts val="0"/>
+                </a:spcAft>
+                <a:buClrTx/>
+                <a:buSzTx/>
+                <a:buFontTx/>
+                <a:buNone/>
+                <a:tabLst/>
+                <a:defRPr/>
+              </a:pPr>
+              <a:r>
+                <a:rPr kumimoji="0" lang="en-US" sz="800" b="0" i="0" u="none" strike="noStrike" kern="0" cap="none" spc="0" normalizeH="0" baseline="0" noProof="0" dirty="0">
+                  <a:ln>
+                    <a:noFill/>
+                  </a:ln>
+                  <a:solidFill>
+                    <a:prstClr val="black"/>
+                  </a:solidFill>
+                  <a:effectLst/>
+                  <a:uLnTx/>
+                  <a:uFillTx/>
+                  <a:latin typeface="Verdana" panose="020B0604030504040204" pitchFamily="34" charset="0"/>
+                  <a:ea typeface="Verdana" panose="020B0604030504040204" pitchFamily="34" charset="0"/>
+                </a:rPr>
+                <a:t>&amp;</a:t>
+              </a:r>
+            </a:p>
+            <a:p>
+              <a:pPr marL="0" marR="0" lvl="0" indent="0" algn="ctr" defTabSz="914400" eaLnBrk="1" fontAlgn="auto" latinLnBrk="0" hangingPunct="1">
+                <a:lnSpc>
+                  <a:spcPct val="100000"/>
+                </a:lnSpc>
+                <a:spcBef>
+                  <a:spcPts val="0"/>
+                </a:spcBef>
+                <a:spcAft>
+                  <a:spcPts val="0"/>
+                </a:spcAft>
+                <a:buClrTx/>
+                <a:buSzTx/>
+                <a:buFontTx/>
+                <a:buNone/>
+                <a:tabLst/>
+                <a:defRPr/>
+              </a:pPr>
+              <a:r>
+                <a:rPr kumimoji="0" lang="en-US" sz="800" b="0" i="0" u="none" strike="noStrike" kern="0" cap="none" spc="0" normalizeH="0" baseline="0" noProof="0" dirty="0">
+                  <a:ln>
+                    <a:noFill/>
+                  </a:ln>
+                  <a:solidFill>
+                    <a:prstClr val="black"/>
+                  </a:solidFill>
+                  <a:effectLst/>
+                  <a:uLnTx/>
+                  <a:uFillTx/>
+                  <a:latin typeface="Verdana" panose="020B0604030504040204" pitchFamily="34" charset="0"/>
+                  <a:ea typeface="Verdana" panose="020B0604030504040204" pitchFamily="34" charset="0"/>
+                </a:rPr>
+                <a:t>Indexing</a:t>
+              </a:r>
+              <a:endParaRPr kumimoji="0" lang="nl-NL" sz="800" b="0" i="0" u="none" strike="noStrike" kern="0" cap="none" spc="0" normalizeH="0" baseline="0" noProof="0" dirty="0" err="1">
+                <a:ln>
+                  <a:noFill/>
+                </a:ln>
+                <a:solidFill>
+                  <a:prstClr val="black"/>
+                </a:solidFill>
+                <a:effectLst/>
+                <a:uLnTx/>
+                <a:uFillTx/>
+                <a:latin typeface="Verdana" panose="020B0604030504040204" pitchFamily="34" charset="0"/>
+                <a:ea typeface="Verdana" panose="020B0604030504040204" pitchFamily="34" charset="0"/>
+              </a:endParaRPr>
+            </a:p>
+          </p:txBody>
+        </p:sp>
+        <p:sp>
+          <p:nvSpPr>
+            <p:cNvPr id="89" name="Arrow: Right 88">
+              <a:extLst>
+                <a:ext uri="{FF2B5EF4-FFF2-40B4-BE49-F238E27FC236}">
+                  <a16:creationId xmlns:a16="http://schemas.microsoft.com/office/drawing/2014/main" id="{2CD4A441-3FAE-4676-583D-4F2D48522C99}"/>
+                </a:ext>
+              </a:extLst>
+            </p:cNvPr>
+            <p:cNvSpPr/>
+            <p:nvPr/>
+          </p:nvSpPr>
+          <p:spPr>
+            <a:xfrm>
+              <a:off x="2269137" y="5464428"/>
+              <a:ext cx="293409" cy="172063"/>
+            </a:xfrm>
+            <a:prstGeom prst="rightArrow">
+              <a:avLst/>
+            </a:prstGeom>
+            <a:solidFill>
+              <a:sysClr val="window" lastClr="FFFFFF">
+                <a:lumMod val="95000"/>
+              </a:sysClr>
+            </a:solidFill>
+            <a:ln w="9525" cap="flat" cmpd="sng" algn="ctr">
+              <a:solidFill>
+                <a:sysClr val="windowText" lastClr="000000"/>
+              </a:solidFill>
+              <a:prstDash val="solid"/>
+              <a:miter lim="800000"/>
+            </a:ln>
+            <a:effectLst/>
+          </p:spPr>
+          <p:txBody>
+            <a:bodyPr rtlCol="0" anchor="ctr"/>
+            <a:lstStyle/>
+            <a:p>
+              <a:pPr marL="0" marR="0" lvl="0" indent="0" algn="ctr" defTabSz="914400" eaLnBrk="1" fontAlgn="auto" latinLnBrk="0" hangingPunct="1">
+                <a:lnSpc>
+                  <a:spcPct val="100000"/>
+                </a:lnSpc>
+                <a:spcBef>
+                  <a:spcPts val="0"/>
+                </a:spcBef>
+                <a:spcAft>
+                  <a:spcPts val="0"/>
+                </a:spcAft>
+                <a:buClrTx/>
+                <a:buSzTx/>
+                <a:buFontTx/>
+                <a:buNone/>
+                <a:tabLst/>
+                <a:defRPr/>
+              </a:pPr>
+              <a:endParaRPr kumimoji="0" lang="nl-NL" sz="1800" b="0" i="0" u="none" strike="noStrike" kern="0" cap="none" spc="0" normalizeH="0" baseline="0" noProof="0">
+                <a:ln>
+                  <a:noFill/>
+                </a:ln>
+                <a:solidFill>
+                  <a:prstClr val="white"/>
+                </a:solidFill>
+                <a:effectLst/>
+                <a:uLnTx/>
+                <a:uFillTx/>
+                <a:latin typeface="Segoe UI Light"/>
+                <a:ea typeface="+mn-ea"/>
+                <a:cs typeface="+mn-cs"/>
+              </a:endParaRPr>
+            </a:p>
+          </p:txBody>
+        </p:sp>
+        <p:sp>
+          <p:nvSpPr>
+            <p:cNvPr id="90" name="Rectangle 89">
+              <a:extLst>
+                <a:ext uri="{FF2B5EF4-FFF2-40B4-BE49-F238E27FC236}">
+                  <a16:creationId xmlns:a16="http://schemas.microsoft.com/office/drawing/2014/main" id="{1C70AB30-1F51-FACE-8DA1-3640E278B04B}"/>
+                </a:ext>
+              </a:extLst>
+            </p:cNvPr>
+            <p:cNvSpPr/>
+            <p:nvPr/>
+          </p:nvSpPr>
+          <p:spPr>
+            <a:xfrm>
+              <a:off x="2686020" y="4929447"/>
+              <a:ext cx="1794540" cy="1242027"/>
+            </a:xfrm>
+            <a:prstGeom prst="rect">
+              <a:avLst/>
+            </a:prstGeom>
+            <a:noFill/>
+            <a:ln w="12700" cap="flat" cmpd="sng" algn="ctr">
+              <a:solidFill>
+                <a:srgbClr val="C4232A">
+                  <a:lumMod val="60000"/>
+                  <a:lumOff val="40000"/>
+                </a:srgbClr>
+              </a:solidFill>
+              <a:prstDash val="dash"/>
+              <a:miter lim="800000"/>
+            </a:ln>
+            <a:effectLst/>
+          </p:spPr>
+          <p:txBody>
+            <a:bodyPr rtlCol="0" anchor="ctr"/>
+            <a:lstStyle/>
+            <a:p>
+              <a:pPr marL="0" marR="0" lvl="0" indent="0" algn="ctr" defTabSz="914400" eaLnBrk="1" fontAlgn="auto" latinLnBrk="0" hangingPunct="1">
+                <a:lnSpc>
+                  <a:spcPct val="100000"/>
+                </a:lnSpc>
+                <a:spcBef>
+                  <a:spcPts val="0"/>
+                </a:spcBef>
+                <a:spcAft>
+                  <a:spcPts val="0"/>
+                </a:spcAft>
+                <a:buClrTx/>
+                <a:buSzTx/>
+                <a:buFontTx/>
+                <a:buNone/>
+                <a:tabLst/>
+                <a:defRPr/>
+              </a:pPr>
+              <a:endParaRPr kumimoji="0" lang="nl-NL" sz="1800" b="0" i="0" u="none" strike="noStrike" kern="0" cap="none" spc="0" normalizeH="0" baseline="0" noProof="0">
+                <a:ln>
+                  <a:noFill/>
+                </a:ln>
+                <a:solidFill>
+                  <a:prstClr val="white"/>
+                </a:solidFill>
+                <a:effectLst/>
+                <a:uLnTx/>
+                <a:uFillTx/>
+                <a:latin typeface="Segoe UI Light"/>
+                <a:ea typeface="+mn-ea"/>
+                <a:cs typeface="+mn-cs"/>
+              </a:endParaRPr>
+            </a:p>
+          </p:txBody>
+        </p:sp>
+      </p:grpSp>
+      <p:pic>
+        <p:nvPicPr>
+          <p:cNvPr id="91" name="Picture 90">
+            <a:extLst>
+              <a:ext uri="{FF2B5EF4-FFF2-40B4-BE49-F238E27FC236}">
+                <a16:creationId xmlns:a16="http://schemas.microsoft.com/office/drawing/2014/main" id="{5BBEF78F-E7EA-F270-FBE4-627774415814}"/>
+              </a:ext>
+            </a:extLst>
+          </p:cNvPr>
+          <p:cNvPicPr>
+            <a:picLocks noChangeAspect="1"/>
+          </p:cNvPicPr>
+          <p:nvPr/>
+        </p:nvPicPr>
+        <p:blipFill>
+          <a:blip r:embed="rId2">
+            <a:clrChange>
+              <a:clrFrom>
+                <a:srgbClr val="F4F4F6"/>
+              </a:clrFrom>
+              <a:clrTo>
+                <a:srgbClr val="F4F4F6">
+                  <a:alpha val="0"/>
+                </a:srgbClr>
+              </a:clrTo>
+            </a:clrChange>
+          </a:blip>
+          <a:stretch>
+            <a:fillRect/>
+          </a:stretch>
+        </p:blipFill>
+        <p:spPr>
+          <a:xfrm>
+            <a:off x="3191613" y="2684787"/>
+            <a:ext cx="370435" cy="349023"/>
+          </a:xfrm>
+          <a:prstGeom prst="rect">
+            <a:avLst/>
+          </a:prstGeom>
+        </p:spPr>
+      </p:pic>
+      <p:cxnSp>
+        <p:nvCxnSpPr>
+          <p:cNvPr id="94" name="Straight Arrow Connector 93">
+            <a:extLst>
+              <a:ext uri="{FF2B5EF4-FFF2-40B4-BE49-F238E27FC236}">
+                <a16:creationId xmlns:a16="http://schemas.microsoft.com/office/drawing/2014/main" id="{0BD1CE13-781E-90D1-4D30-DAB668CE82F4}"/>
+              </a:ext>
+            </a:extLst>
+          </p:cNvPr>
+          <p:cNvCxnSpPr>
+            <a:cxnSpLocks/>
+          </p:cNvCxnSpPr>
+          <p:nvPr/>
+        </p:nvCxnSpPr>
+        <p:spPr>
+          <a:xfrm flipV="1">
+            <a:off x="3122685" y="2731184"/>
+            <a:ext cx="0" cy="274320"/>
+          </a:xfrm>
+          <a:prstGeom prst="straightConnector1">
+            <a:avLst/>
+          </a:prstGeom>
+          <a:ln w="19050" cap="flat" cmpd="sng" algn="ctr">
+            <a:solidFill>
+              <a:schemeClr val="accent3"/>
+            </a:solidFill>
+            <a:prstDash val="solid"/>
+            <a:round/>
+            <a:headEnd type="none" w="med" len="med"/>
+            <a:tailEnd type="arrow" w="med" len="med"/>
+          </a:ln>
+        </p:spPr>
+        <p:style>
+          <a:lnRef idx="0">
+            <a:scrgbClr r="0" g="0" b="0"/>
+          </a:lnRef>
+          <a:fillRef idx="0">
+            <a:scrgbClr r="0" g="0" b="0"/>
+          </a:fillRef>
+          <a:effectRef idx="0">
+            <a:scrgbClr r="0" g="0" b="0"/>
+          </a:effectRef>
+          <a:fontRef idx="minor">
+            <a:schemeClr val="tx1"/>
+          </a:fontRef>
+        </p:style>
+      </p:cxnSp>
+      <p:grpSp>
+        <p:nvGrpSpPr>
+          <p:cNvPr id="96" name="Group 95">
+            <a:extLst>
+              <a:ext uri="{FF2B5EF4-FFF2-40B4-BE49-F238E27FC236}">
+                <a16:creationId xmlns:a16="http://schemas.microsoft.com/office/drawing/2014/main" id="{D570DF7C-8A62-C81A-43B3-4DFD59F2EB4D}"/>
+              </a:ext>
+            </a:extLst>
+          </p:cNvPr>
+          <p:cNvGrpSpPr/>
+          <p:nvPr/>
+        </p:nvGrpSpPr>
+        <p:grpSpPr>
+          <a:xfrm>
+            <a:off x="2419147" y="1748558"/>
+            <a:ext cx="1862635" cy="584775"/>
+            <a:chOff x="2961190" y="3065338"/>
+            <a:chExt cx="1862635" cy="584775"/>
+          </a:xfrm>
+        </p:grpSpPr>
+        <p:sp>
+          <p:nvSpPr>
+            <p:cNvPr id="98" name="Rectangle: Rounded Corners 97">
+              <a:extLst>
+                <a:ext uri="{FF2B5EF4-FFF2-40B4-BE49-F238E27FC236}">
+                  <a16:creationId xmlns:a16="http://schemas.microsoft.com/office/drawing/2014/main" id="{7C39A6FF-D997-AF5F-F5CD-D5096C6C845F}"/>
+                </a:ext>
+              </a:extLst>
+            </p:cNvPr>
+            <p:cNvSpPr/>
+            <p:nvPr/>
+          </p:nvSpPr>
+          <p:spPr>
+            <a:xfrm>
+              <a:off x="3010964" y="3067514"/>
+              <a:ext cx="1812861" cy="548639"/>
+            </a:xfrm>
+            <a:prstGeom prst="roundRect">
+              <a:avLst/>
+            </a:prstGeom>
+            <a:solidFill>
+              <a:srgbClr val="FFC000">
+                <a:alpha val="24000"/>
+              </a:srgbClr>
+            </a:solidFill>
+            <a:ln w="12700" cap="flat" cmpd="sng" algn="ctr">
+              <a:solidFill>
+                <a:srgbClr val="3C9BD5">
+                  <a:shade val="15000"/>
+                </a:srgbClr>
+              </a:solidFill>
+              <a:prstDash val="solid"/>
+              <a:miter lim="800000"/>
+            </a:ln>
+            <a:effectLst/>
+          </p:spPr>
+          <p:txBody>
+            <a:bodyPr rtlCol="0" anchor="ctr"/>
+            <a:lstStyle/>
+            <a:p>
+              <a:pPr marL="0" marR="0" lvl="0" indent="0" algn="ctr" defTabSz="914400" eaLnBrk="1" fontAlgn="auto" latinLnBrk="0" hangingPunct="1">
+                <a:lnSpc>
+                  <a:spcPct val="100000"/>
+                </a:lnSpc>
+                <a:spcBef>
+                  <a:spcPts val="0"/>
+                </a:spcBef>
+                <a:spcAft>
+                  <a:spcPts val="0"/>
+                </a:spcAft>
+                <a:buClrTx/>
+                <a:buSzTx/>
+                <a:buFontTx/>
+                <a:buNone/>
+                <a:tabLst/>
+                <a:defRPr/>
+              </a:pPr>
+              <a:endParaRPr kumimoji="0" lang="nl-NL" sz="1800" b="0" i="0" u="none" strike="noStrike" kern="0" cap="none" spc="0" normalizeH="0" baseline="0" noProof="0">
+                <a:ln>
+                  <a:noFill/>
+                </a:ln>
+                <a:solidFill>
+                  <a:prstClr val="white"/>
+                </a:solidFill>
+                <a:effectLst/>
+                <a:uLnTx/>
+                <a:uFillTx/>
+                <a:latin typeface="Segoe UI Light"/>
+                <a:ea typeface="+mn-ea"/>
+                <a:cs typeface="+mn-cs"/>
+              </a:endParaRPr>
+            </a:p>
+          </p:txBody>
+        </p:sp>
+        <p:sp>
+          <p:nvSpPr>
+            <p:cNvPr id="99" name="TextBox 98">
+              <a:extLst>
+                <a:ext uri="{FF2B5EF4-FFF2-40B4-BE49-F238E27FC236}">
+                  <a16:creationId xmlns:a16="http://schemas.microsoft.com/office/drawing/2014/main" id="{7E0F777C-C89C-F41A-DFA9-9060AD5A2B3D}"/>
+                </a:ext>
+              </a:extLst>
+            </p:cNvPr>
+            <p:cNvSpPr txBox="1"/>
+            <p:nvPr/>
+          </p:nvSpPr>
+          <p:spPr>
+            <a:xfrm>
+              <a:off x="2961190" y="3065338"/>
+              <a:ext cx="1647036" cy="584775"/>
+            </a:xfrm>
+            <a:prstGeom prst="rect">
+              <a:avLst/>
+            </a:prstGeom>
+            <a:noFill/>
+          </p:spPr>
+          <p:txBody>
+            <a:bodyPr wrap="square" rtlCol="0">
+              <a:spAutoFit/>
+            </a:bodyPr>
+            <a:lstStyle/>
+            <a:p>
+              <a:pPr marL="0" marR="0" lvl="0" indent="0" defTabSz="914400" eaLnBrk="1" fontAlgn="auto" latinLnBrk="0" hangingPunct="1">
+                <a:lnSpc>
+                  <a:spcPct val="100000"/>
+                </a:lnSpc>
+                <a:spcBef>
+                  <a:spcPts val="0"/>
+                </a:spcBef>
+                <a:spcAft>
+                  <a:spcPts val="0"/>
+                </a:spcAft>
+                <a:buClrTx/>
+                <a:buSzTx/>
+                <a:buFontTx/>
+                <a:buNone/>
+                <a:tabLst/>
+                <a:defRPr/>
+              </a:pPr>
+              <a:r>
+                <a:rPr kumimoji="0" lang="en-US" sz="800" b="0" i="0" u="none" strike="noStrike" kern="0" cap="none" spc="0" normalizeH="0" baseline="0" noProof="0" dirty="0">
+                  <a:ln>
+                    <a:noFill/>
+                  </a:ln>
+                  <a:solidFill>
+                    <a:prstClr val="black"/>
+                  </a:solidFill>
+                  <a:effectLst/>
+                  <a:uLnTx/>
+                  <a:uFillTx/>
+                  <a:latin typeface="Verdana" panose="020B0604030504040204" pitchFamily="34" charset="0"/>
+                  <a:ea typeface="Verdana" panose="020B0604030504040204" pitchFamily="34" charset="0"/>
+                </a:rPr>
+                <a:t>- Retrieve last N summaries</a:t>
+              </a:r>
+            </a:p>
+            <a:p>
+              <a:pPr marL="0" marR="0" lvl="0" indent="0" defTabSz="914400" eaLnBrk="1" fontAlgn="auto" latinLnBrk="0" hangingPunct="1">
+                <a:lnSpc>
+                  <a:spcPct val="100000"/>
+                </a:lnSpc>
+                <a:spcBef>
+                  <a:spcPts val="0"/>
+                </a:spcBef>
+                <a:spcAft>
+                  <a:spcPts val="0"/>
+                </a:spcAft>
+                <a:buClrTx/>
+                <a:buSzTx/>
+                <a:buFontTx/>
+                <a:buNone/>
+                <a:tabLst/>
+                <a:defRPr/>
+              </a:pPr>
+              <a:r>
+                <a:rPr lang="en-US" sz="800" kern="0" dirty="0">
+                  <a:solidFill>
+                    <a:prstClr val="black"/>
+                  </a:solidFill>
+                  <a:latin typeface="Verdana" panose="020B0604030504040204" pitchFamily="34" charset="0"/>
+                  <a:ea typeface="Verdana" panose="020B0604030504040204" pitchFamily="34" charset="0"/>
+                </a:rPr>
+                <a:t>- Add current chunk</a:t>
+              </a:r>
+            </a:p>
+            <a:p>
+              <a:pPr marL="0" marR="0" lvl="0" indent="0" defTabSz="914400" eaLnBrk="1" fontAlgn="auto" latinLnBrk="0" hangingPunct="1">
+                <a:lnSpc>
+                  <a:spcPct val="100000"/>
+                </a:lnSpc>
+                <a:spcBef>
+                  <a:spcPts val="0"/>
+                </a:spcBef>
+                <a:spcAft>
+                  <a:spcPts val="0"/>
+                </a:spcAft>
+                <a:buClrTx/>
+                <a:buSzTx/>
+                <a:buFontTx/>
+                <a:buNone/>
+                <a:tabLst/>
+                <a:defRPr/>
+              </a:pPr>
+              <a:r>
+                <a:rPr kumimoji="0" lang="nl-NL" sz="800" b="0" i="0" u="none" strike="noStrike" kern="0" cap="none" spc="0" normalizeH="0" baseline="0" noProof="0" dirty="0">
+                  <a:ln>
+                    <a:noFill/>
+                  </a:ln>
+                  <a:solidFill>
+                    <a:prstClr val="black"/>
+                  </a:solidFill>
+                  <a:effectLst/>
+                  <a:uLnTx/>
+                  <a:uFillTx/>
+                  <a:latin typeface="Verdana" panose="020B0604030504040204" pitchFamily="34" charset="0"/>
+                  <a:ea typeface="Verdana" panose="020B0604030504040204" pitchFamily="34" charset="0"/>
+                </a:rPr>
+                <a:t>- Add Instructions + Query</a:t>
+              </a:r>
+            </a:p>
+            <a:p>
+              <a:pPr marL="0" marR="0" lvl="0" indent="0" defTabSz="914400" eaLnBrk="1" fontAlgn="auto" latinLnBrk="0" hangingPunct="1">
+                <a:lnSpc>
+                  <a:spcPct val="100000"/>
+                </a:lnSpc>
+                <a:spcBef>
+                  <a:spcPts val="0"/>
+                </a:spcBef>
+                <a:spcAft>
+                  <a:spcPts val="0"/>
+                </a:spcAft>
+                <a:buClrTx/>
+                <a:buSzTx/>
+                <a:buFontTx/>
+                <a:buNone/>
+                <a:tabLst/>
+                <a:defRPr/>
+              </a:pPr>
+              <a:r>
+                <a:rPr kumimoji="0" lang="nl-NL" sz="800" b="0" i="0" u="none" strike="noStrike" kern="0" cap="none" spc="0" normalizeH="0" baseline="0" noProof="0" dirty="0">
+                  <a:ln>
+                    <a:noFill/>
+                  </a:ln>
+                  <a:solidFill>
+                    <a:prstClr val="black"/>
+                  </a:solidFill>
+                  <a:effectLst/>
+                  <a:uLnTx/>
+                  <a:uFillTx/>
+                  <a:latin typeface="Verdana" panose="020B0604030504040204" pitchFamily="34" charset="0"/>
+                  <a:ea typeface="Verdana" panose="020B0604030504040204" pitchFamily="34" charset="0"/>
+                </a:rPr>
+                <a:t>- Send Prompt to LLM</a:t>
+              </a:r>
+            </a:p>
+          </p:txBody>
+        </p:sp>
+      </p:grpSp>
+      <p:grpSp>
+        <p:nvGrpSpPr>
+          <p:cNvPr id="101" name="Group 100">
+            <a:extLst>
+              <a:ext uri="{FF2B5EF4-FFF2-40B4-BE49-F238E27FC236}">
+                <a16:creationId xmlns:a16="http://schemas.microsoft.com/office/drawing/2014/main" id="{8BE059F2-1350-E65E-EA76-162F7D1512F8}"/>
+              </a:ext>
+            </a:extLst>
+          </p:cNvPr>
+          <p:cNvGrpSpPr/>
+          <p:nvPr/>
+        </p:nvGrpSpPr>
+        <p:grpSpPr>
+          <a:xfrm>
+            <a:off x="4477965" y="1750734"/>
+            <a:ext cx="1040927" cy="548639"/>
+            <a:chOff x="3160592" y="3067514"/>
+            <a:chExt cx="1297881" cy="548639"/>
+          </a:xfrm>
+        </p:grpSpPr>
+        <p:sp>
+          <p:nvSpPr>
+            <p:cNvPr id="103" name="Rectangle: Rounded Corners 102">
+              <a:extLst>
+                <a:ext uri="{FF2B5EF4-FFF2-40B4-BE49-F238E27FC236}">
+                  <a16:creationId xmlns:a16="http://schemas.microsoft.com/office/drawing/2014/main" id="{BF6A94C0-1457-5884-E621-A61C8C7D2DC8}"/>
+                </a:ext>
+              </a:extLst>
+            </p:cNvPr>
+            <p:cNvSpPr/>
+            <p:nvPr/>
+          </p:nvSpPr>
+          <p:spPr>
+            <a:xfrm>
+              <a:off x="3195952" y="3067514"/>
+              <a:ext cx="1109383" cy="548639"/>
+            </a:xfrm>
+            <a:prstGeom prst="roundRect">
+              <a:avLst/>
+            </a:prstGeom>
+            <a:solidFill>
+              <a:srgbClr val="FFC000">
+                <a:alpha val="24000"/>
+              </a:srgbClr>
+            </a:solidFill>
+            <a:ln w="12700" cap="flat" cmpd="sng" algn="ctr">
+              <a:solidFill>
+                <a:srgbClr val="3C9BD5">
+                  <a:shade val="15000"/>
+                </a:srgbClr>
+              </a:solidFill>
+              <a:prstDash val="solid"/>
+              <a:miter lim="800000"/>
+            </a:ln>
+            <a:effectLst/>
+          </p:spPr>
+          <p:txBody>
+            <a:bodyPr rtlCol="0" anchor="ctr"/>
+            <a:lstStyle/>
+            <a:p>
+              <a:pPr marL="0" marR="0" lvl="0" indent="0" algn="ctr" defTabSz="914400" eaLnBrk="1" fontAlgn="auto" latinLnBrk="0" hangingPunct="1">
+                <a:lnSpc>
+                  <a:spcPct val="100000"/>
+                </a:lnSpc>
+                <a:spcBef>
+                  <a:spcPts val="0"/>
+                </a:spcBef>
+                <a:spcAft>
+                  <a:spcPts val="0"/>
+                </a:spcAft>
+                <a:buClrTx/>
+                <a:buSzTx/>
+                <a:buFontTx/>
+                <a:buNone/>
+                <a:tabLst/>
+                <a:defRPr/>
+              </a:pPr>
+              <a:endParaRPr kumimoji="0" lang="nl-NL" sz="1800" b="0" i="0" u="none" strike="noStrike" kern="0" cap="none" spc="0" normalizeH="0" baseline="0" noProof="0">
+                <a:ln>
+                  <a:noFill/>
+                </a:ln>
+                <a:solidFill>
+                  <a:prstClr val="white"/>
+                </a:solidFill>
+                <a:effectLst/>
+                <a:uLnTx/>
+                <a:uFillTx/>
+                <a:latin typeface="Segoe UI Light"/>
+                <a:ea typeface="+mn-ea"/>
+                <a:cs typeface="+mn-cs"/>
+              </a:endParaRPr>
+            </a:p>
+          </p:txBody>
+        </p:sp>
+        <p:sp>
+          <p:nvSpPr>
+            <p:cNvPr id="104" name="TextBox 103">
+              <a:extLst>
+                <a:ext uri="{FF2B5EF4-FFF2-40B4-BE49-F238E27FC236}">
+                  <a16:creationId xmlns:a16="http://schemas.microsoft.com/office/drawing/2014/main" id="{67FA9D7D-D8FF-582F-377C-9879BCDCA71E}"/>
+                </a:ext>
+              </a:extLst>
+            </p:cNvPr>
+            <p:cNvSpPr txBox="1"/>
+            <p:nvPr/>
+          </p:nvSpPr>
+          <p:spPr>
+            <a:xfrm>
+              <a:off x="3160592" y="3163175"/>
+              <a:ext cx="1297881" cy="338554"/>
+            </a:xfrm>
+            <a:prstGeom prst="rect">
+              <a:avLst/>
+            </a:prstGeom>
+            <a:noFill/>
+          </p:spPr>
+          <p:txBody>
+            <a:bodyPr wrap="square" rtlCol="0">
+              <a:spAutoFit/>
+            </a:bodyPr>
+            <a:lstStyle/>
+            <a:p>
+              <a:pPr marL="0" marR="0" lvl="0" indent="0" defTabSz="914400" eaLnBrk="1" fontAlgn="auto" latinLnBrk="0" hangingPunct="1">
+                <a:lnSpc>
+                  <a:spcPct val="100000"/>
+                </a:lnSpc>
+                <a:spcBef>
+                  <a:spcPts val="0"/>
+                </a:spcBef>
+                <a:spcAft>
+                  <a:spcPts val="0"/>
+                </a:spcAft>
+                <a:buClrTx/>
+                <a:buSzTx/>
+                <a:buFontTx/>
+                <a:buNone/>
+                <a:tabLst/>
+                <a:defRPr/>
+              </a:pPr>
+              <a:r>
+                <a:rPr kumimoji="0" lang="en-US" sz="800" b="0" i="0" u="none" strike="noStrike" kern="0" cap="none" spc="0" normalizeH="0" baseline="0" noProof="0" dirty="0">
+                  <a:ln>
+                    <a:noFill/>
+                  </a:ln>
+                  <a:solidFill>
+                    <a:prstClr val="black"/>
+                  </a:solidFill>
+                  <a:effectLst/>
+                  <a:uLnTx/>
+                  <a:uFillTx/>
+                  <a:latin typeface="Verdana" panose="020B0604030504040204" pitchFamily="34" charset="0"/>
+                  <a:ea typeface="Verdana" panose="020B0604030504040204" pitchFamily="34" charset="0"/>
+                </a:rPr>
+                <a:t>Append partial result to list</a:t>
+              </a:r>
+              <a:endParaRPr kumimoji="0" lang="nl-NL" sz="800" b="0" i="0" u="none" strike="noStrike" kern="0" cap="none" spc="0" normalizeH="0" baseline="0" noProof="0" dirty="0" err="1">
+                <a:ln>
+                  <a:noFill/>
+                </a:ln>
+                <a:solidFill>
+                  <a:prstClr val="black"/>
+                </a:solidFill>
+                <a:effectLst/>
+                <a:uLnTx/>
+                <a:uFillTx/>
+                <a:latin typeface="Verdana" panose="020B0604030504040204" pitchFamily="34" charset="0"/>
+                <a:ea typeface="Verdana" panose="020B0604030504040204" pitchFamily="34" charset="0"/>
+              </a:endParaRPr>
+            </a:p>
+          </p:txBody>
+        </p:sp>
+      </p:grpSp>
+      <p:pic>
+        <p:nvPicPr>
+          <p:cNvPr id="108" name="Picture 2" descr="Bot (informática) - EcuRed">
+            <a:extLst>
+              <a:ext uri="{FF2B5EF4-FFF2-40B4-BE49-F238E27FC236}">
+                <a16:creationId xmlns:a16="http://schemas.microsoft.com/office/drawing/2014/main" id="{38E5DCFD-FE47-A683-79A5-08298210F18D}"/>
+              </a:ext>
+            </a:extLst>
+          </p:cNvPr>
+          <p:cNvPicPr>
+            <a:picLocks noChangeAspect="1" noChangeArrowheads="1"/>
+          </p:cNvPicPr>
+          <p:nvPr/>
+        </p:nvPicPr>
+        <p:blipFill rotWithShape="1">
+          <a:blip r:embed="rId3">
+            <a:clrChange>
+              <a:clrFrom>
+                <a:srgbClr val="FFFFFF"/>
+              </a:clrFrom>
+              <a:clrTo>
+                <a:srgbClr val="FFFFFF">
+                  <a:alpha val="0"/>
+                </a:srgbClr>
+              </a:clrTo>
+            </a:clrChange>
+            <a:duotone>
+              <a:srgbClr val="3C9BD5">
+                <a:shade val="45000"/>
+                <a:satMod val="135000"/>
+              </a:srgbClr>
+              <a:prstClr val="white"/>
+            </a:duotone>
+            <a:extLst>
+              <a:ext uri="{28A0092B-C50C-407E-A947-70E740481C1C}">
+                <a14:useLocalDpi xmlns:a14="http://schemas.microsoft.com/office/drawing/2010/main" val="0"/>
+              </a:ext>
+            </a:extLst>
+          </a:blip>
+          <a:srcRect l="18962" t="6530" r="16637" b="12432"/>
+          <a:stretch/>
+        </p:blipFill>
+        <p:spPr bwMode="auto">
+          <a:xfrm>
+            <a:off x="5843751" y="3375679"/>
+            <a:ext cx="381057" cy="479497"/>
+          </a:xfrm>
+          <a:prstGeom prst="rect">
+            <a:avLst/>
+          </a:prstGeom>
+          <a:noFill/>
+          <a:extLst>
+            <a:ext uri="{909E8E84-426E-40DD-AFC4-6F175D3DCCD1}">
+              <a14:hiddenFill xmlns:a14="http://schemas.microsoft.com/office/drawing/2010/main">
+                <a:solidFill>
+                  <a:srgbClr val="FFFFFF"/>
+                </a:solidFill>
+              </a14:hiddenFill>
+            </a:ext>
+          </a:extLst>
+        </p:spPr>
+      </p:pic>
+      <p:sp>
+        <p:nvSpPr>
+          <p:cNvPr id="138" name="Rectangle 137">
+            <a:extLst>
+              <a:ext uri="{FF2B5EF4-FFF2-40B4-BE49-F238E27FC236}">
+                <a16:creationId xmlns:a16="http://schemas.microsoft.com/office/drawing/2014/main" id="{9FCAF378-10F3-3756-067E-FA20E0EEB8AC}"/>
+              </a:ext>
+            </a:extLst>
+          </p:cNvPr>
+          <p:cNvSpPr/>
+          <p:nvPr/>
+        </p:nvSpPr>
+        <p:spPr>
+          <a:xfrm>
+            <a:off x="2403149" y="1600120"/>
+            <a:ext cx="3074425" cy="958275"/>
+          </a:xfrm>
+          <a:prstGeom prst="rect">
+            <a:avLst/>
+          </a:prstGeom>
+          <a:noFill/>
+          <a:ln w="12700" cap="flat" cmpd="sng" algn="ctr">
+            <a:solidFill>
+              <a:srgbClr val="C4232A">
+                <a:lumMod val="60000"/>
+                <a:lumOff val="40000"/>
+              </a:srgbClr>
+            </a:solidFill>
+            <a:prstDash val="dash"/>
+            <a:miter lim="800000"/>
+          </a:ln>
+          <a:effectLst/>
+        </p:spPr>
+        <p:txBody>
+          <a:bodyPr rtlCol="0" anchor="ctr"/>
+          <a:lstStyle/>
+          <a:p>
+            <a:pPr marL="0" marR="0" lvl="0" indent="0" algn="ctr" defTabSz="914400" eaLnBrk="1" fontAlgn="auto" latinLnBrk="0" hangingPunct="1">
+              <a:lnSpc>
+                <a:spcPct val="100000"/>
+              </a:lnSpc>
+              <a:spcBef>
+                <a:spcPts val="0"/>
+              </a:spcBef>
+              <a:spcAft>
+                <a:spcPts val="0"/>
+              </a:spcAft>
+              <a:buClrTx/>
+              <a:buSzTx/>
+              <a:buFontTx/>
+              <a:buNone/>
+              <a:tabLst/>
+              <a:defRPr/>
+            </a:pPr>
+            <a:endParaRPr kumimoji="0" lang="nl-NL" sz="1800" b="0" i="0" u="none" strike="noStrike" kern="0" cap="none" spc="0" normalizeH="0" baseline="0" noProof="0">
+              <a:ln>
+                <a:noFill/>
+              </a:ln>
+              <a:solidFill>
+                <a:prstClr val="white"/>
+              </a:solidFill>
+              <a:effectLst/>
+              <a:uLnTx/>
+              <a:uFillTx/>
+              <a:latin typeface="Segoe UI Light"/>
+              <a:ea typeface="+mn-ea"/>
+              <a:cs typeface="+mn-cs"/>
+            </a:endParaRPr>
+          </a:p>
+        </p:txBody>
+      </p:sp>
+      <p:sp>
+        <p:nvSpPr>
+          <p:cNvPr id="141" name="TextBox 140">
+            <a:extLst>
+              <a:ext uri="{FF2B5EF4-FFF2-40B4-BE49-F238E27FC236}">
+                <a16:creationId xmlns:a16="http://schemas.microsoft.com/office/drawing/2014/main" id="{3DB36235-9051-F190-A5BC-FAFBC153D022}"/>
+              </a:ext>
+            </a:extLst>
+          </p:cNvPr>
+          <p:cNvSpPr txBox="1"/>
+          <p:nvPr/>
+        </p:nvSpPr>
+        <p:spPr>
+          <a:xfrm>
+            <a:off x="5667277" y="3890780"/>
+            <a:ext cx="754288" cy="338554"/>
+          </a:xfrm>
+          <a:prstGeom prst="rect">
+            <a:avLst/>
+          </a:prstGeom>
+          <a:noFill/>
+        </p:spPr>
+        <p:txBody>
+          <a:bodyPr wrap="square" rtlCol="0">
+            <a:spAutoFit/>
+          </a:bodyPr>
+          <a:lstStyle/>
+          <a:p>
+            <a:pPr algn="ctr"/>
+            <a:r>
+              <a:rPr lang="en-US" sz="800" b="1" dirty="0">
+                <a:solidFill>
+                  <a:prstClr val="black"/>
+                </a:solidFill>
+                <a:latin typeface="Verdana" panose="020B0604030504040204" pitchFamily="34" charset="0"/>
+                <a:ea typeface="Verdana" panose="020B0604030504040204" pitchFamily="34" charset="0"/>
+              </a:rPr>
+              <a:t>Language</a:t>
+            </a:r>
+          </a:p>
+          <a:p>
+            <a:pPr algn="ctr"/>
+            <a:r>
+              <a:rPr lang="en-US" sz="800" b="1" dirty="0">
+                <a:solidFill>
+                  <a:prstClr val="black"/>
+                </a:solidFill>
+                <a:latin typeface="Verdana" panose="020B0604030504040204" pitchFamily="34" charset="0"/>
+                <a:ea typeface="Verdana" panose="020B0604030504040204" pitchFamily="34" charset="0"/>
+              </a:rPr>
+              <a:t>Model</a:t>
+            </a:r>
+            <a:endParaRPr lang="nl-NL" sz="800" b="1" dirty="0" err="1">
+              <a:solidFill>
+                <a:prstClr val="black"/>
+              </a:solidFill>
+              <a:latin typeface="Verdana" panose="020B0604030504040204" pitchFamily="34" charset="0"/>
+              <a:ea typeface="Verdana" panose="020B0604030504040204" pitchFamily="34" charset="0"/>
+            </a:endParaRPr>
+          </a:p>
+        </p:txBody>
+      </p:sp>
+      <p:cxnSp>
+        <p:nvCxnSpPr>
+          <p:cNvPr id="149" name="Straight Arrow Connector 148">
+            <a:extLst>
+              <a:ext uri="{FF2B5EF4-FFF2-40B4-BE49-F238E27FC236}">
+                <a16:creationId xmlns:a16="http://schemas.microsoft.com/office/drawing/2014/main" id="{A3522D56-DCCA-EECB-7C09-2BB28B3A496C}"/>
+              </a:ext>
+            </a:extLst>
+          </p:cNvPr>
+          <p:cNvCxnSpPr>
+            <a:cxnSpLocks/>
+          </p:cNvCxnSpPr>
+          <p:nvPr/>
+        </p:nvCxnSpPr>
+        <p:spPr>
+          <a:xfrm>
+            <a:off x="4298963" y="2141648"/>
+            <a:ext cx="180000" cy="0"/>
+          </a:xfrm>
+          <a:prstGeom prst="straightConnector1">
+            <a:avLst/>
+          </a:prstGeom>
+          <a:ln w="19050" cap="flat" cmpd="sng" algn="ctr">
+            <a:solidFill>
+              <a:schemeClr val="accent3"/>
+            </a:solidFill>
+            <a:prstDash val="solid"/>
+            <a:round/>
+            <a:headEnd type="none" w="med" len="med"/>
+            <a:tailEnd type="arrow" w="med" len="med"/>
+          </a:ln>
+        </p:spPr>
+        <p:style>
+          <a:lnRef idx="0">
+            <a:scrgbClr r="0" g="0" b="0"/>
+          </a:lnRef>
+          <a:fillRef idx="0">
+            <a:scrgbClr r="0" g="0" b="0"/>
+          </a:fillRef>
+          <a:effectRef idx="0">
+            <a:scrgbClr r="0" g="0" b="0"/>
+          </a:effectRef>
+          <a:fontRef idx="minor">
+            <a:schemeClr val="tx1"/>
+          </a:fontRef>
+        </p:style>
+      </p:cxnSp>
+      <p:pic>
+        <p:nvPicPr>
+          <p:cNvPr id="156" name="Picture 155">
+            <a:extLst>
+              <a:ext uri="{FF2B5EF4-FFF2-40B4-BE49-F238E27FC236}">
+                <a16:creationId xmlns:a16="http://schemas.microsoft.com/office/drawing/2014/main" id="{9B2F6680-0DFB-6E89-0D06-FC4BB56D9D29}"/>
+              </a:ext>
+            </a:extLst>
+          </p:cNvPr>
+          <p:cNvPicPr>
+            <a:picLocks noChangeAspect="1"/>
+          </p:cNvPicPr>
+          <p:nvPr/>
+        </p:nvPicPr>
+        <p:blipFill>
+          <a:blip r:embed="rId4">
+            <a:clrChange>
+              <a:clrFrom>
+                <a:srgbClr val="F4F4F6"/>
+              </a:clrFrom>
+              <a:clrTo>
+                <a:srgbClr val="F4F4F6">
+                  <a:alpha val="0"/>
+                </a:srgbClr>
+              </a:clrTo>
+            </a:clrChange>
+          </a:blip>
+          <a:stretch>
+            <a:fillRect/>
+          </a:stretch>
+        </p:blipFill>
+        <p:spPr>
+          <a:xfrm>
+            <a:off x="7181598" y="3506787"/>
+            <a:ext cx="507697" cy="523199"/>
+          </a:xfrm>
+          <a:prstGeom prst="rect">
+            <a:avLst/>
+          </a:prstGeom>
+        </p:spPr>
+      </p:pic>
+      <p:sp>
+        <p:nvSpPr>
+          <p:cNvPr id="157" name="TextBox 156">
+            <a:extLst>
+              <a:ext uri="{FF2B5EF4-FFF2-40B4-BE49-F238E27FC236}">
+                <a16:creationId xmlns:a16="http://schemas.microsoft.com/office/drawing/2014/main" id="{02C5A887-C98D-4C80-6596-9913B522E9C3}"/>
+              </a:ext>
+            </a:extLst>
+          </p:cNvPr>
+          <p:cNvSpPr txBox="1"/>
+          <p:nvPr/>
+        </p:nvSpPr>
+        <p:spPr>
+          <a:xfrm>
+            <a:off x="6446225" y="3913744"/>
+            <a:ext cx="540533" cy="215444"/>
+          </a:xfrm>
+          <a:prstGeom prst="rect">
+            <a:avLst/>
+          </a:prstGeom>
+          <a:noFill/>
+        </p:spPr>
+        <p:txBody>
+          <a:bodyPr wrap="none" rtlCol="0">
+            <a:spAutoFit/>
+          </a:bodyPr>
+          <a:lstStyle/>
+          <a:p>
+            <a:pPr algn="ctr"/>
+            <a:r>
+              <a:rPr lang="en-US" sz="800" dirty="0">
+                <a:latin typeface="Verdana" panose="020B0604030504040204" pitchFamily="34" charset="0"/>
+                <a:ea typeface="Verdana" panose="020B0604030504040204" pitchFamily="34" charset="0"/>
+              </a:rPr>
+              <a:t>Output</a:t>
+            </a:r>
+          </a:p>
+        </p:txBody>
+      </p:sp>
+      <p:cxnSp>
+        <p:nvCxnSpPr>
+          <p:cNvPr id="158" name="Straight Arrow Connector 157">
+            <a:extLst>
+              <a:ext uri="{FF2B5EF4-FFF2-40B4-BE49-F238E27FC236}">
+                <a16:creationId xmlns:a16="http://schemas.microsoft.com/office/drawing/2014/main" id="{A9C6D676-7C32-98E9-0780-02D442D351AF}"/>
+              </a:ext>
+            </a:extLst>
+          </p:cNvPr>
+          <p:cNvCxnSpPr>
+            <a:cxnSpLocks/>
+          </p:cNvCxnSpPr>
+          <p:nvPr/>
+        </p:nvCxnSpPr>
+        <p:spPr>
+          <a:xfrm>
+            <a:off x="5574423" y="2101586"/>
+            <a:ext cx="324000" cy="0"/>
+          </a:xfrm>
+          <a:prstGeom prst="straightConnector1">
+            <a:avLst/>
+          </a:prstGeom>
+          <a:ln w="19050" cap="flat" cmpd="sng" algn="ctr">
+            <a:solidFill>
+              <a:schemeClr val="accent3"/>
+            </a:solidFill>
+            <a:prstDash val="solid"/>
+            <a:round/>
+            <a:headEnd type="none" w="med" len="med"/>
+            <a:tailEnd type="arrow" w="med" len="med"/>
+          </a:ln>
+        </p:spPr>
+        <p:style>
+          <a:lnRef idx="0">
+            <a:scrgbClr r="0" g="0" b="0"/>
+          </a:lnRef>
+          <a:fillRef idx="0">
+            <a:scrgbClr r="0" g="0" b="0"/>
+          </a:fillRef>
+          <a:effectRef idx="0">
+            <a:scrgbClr r="0" g="0" b="0"/>
+          </a:effectRef>
+          <a:fontRef idx="minor">
+            <a:schemeClr val="tx1"/>
+          </a:fontRef>
+        </p:style>
+      </p:cxnSp>
+      <p:sp>
+        <p:nvSpPr>
+          <p:cNvPr id="163" name="TextBox 162">
+            <a:extLst>
+              <a:ext uri="{FF2B5EF4-FFF2-40B4-BE49-F238E27FC236}">
+                <a16:creationId xmlns:a16="http://schemas.microsoft.com/office/drawing/2014/main" id="{456DE010-F3A7-C85E-DF6E-F12709326CB6}"/>
+              </a:ext>
+            </a:extLst>
+          </p:cNvPr>
+          <p:cNvSpPr txBox="1"/>
+          <p:nvPr/>
+        </p:nvSpPr>
+        <p:spPr>
+          <a:xfrm>
+            <a:off x="2418237" y="1361227"/>
+            <a:ext cx="3055365" cy="246221"/>
+          </a:xfrm>
+          <a:prstGeom prst="rect">
+            <a:avLst/>
+          </a:prstGeom>
+          <a:noFill/>
+        </p:spPr>
+        <p:txBody>
+          <a:bodyPr wrap="square" rtlCol="0">
+            <a:spAutoFit/>
+          </a:bodyPr>
+          <a:lstStyle/>
+          <a:p>
+            <a:pPr algn="ctr"/>
+            <a:r>
+              <a:rPr lang="en-US" sz="1000" b="1" dirty="0">
+                <a:solidFill>
+                  <a:prstClr val="black"/>
+                </a:solidFill>
+                <a:latin typeface="Verdana" panose="020B0604030504040204" pitchFamily="34" charset="0"/>
+                <a:ea typeface="Verdana" panose="020B0604030504040204" pitchFamily="34" charset="0"/>
+              </a:rPr>
+              <a:t>Chunk-Loop</a:t>
+            </a:r>
+            <a:endParaRPr lang="nl-NL" sz="1000" b="1" dirty="0" err="1">
+              <a:solidFill>
+                <a:prstClr val="black"/>
+              </a:solidFill>
+              <a:latin typeface="Verdana" panose="020B0604030504040204" pitchFamily="34" charset="0"/>
+              <a:ea typeface="Verdana" panose="020B0604030504040204" pitchFamily="34" charset="0"/>
+            </a:endParaRPr>
+          </a:p>
+        </p:txBody>
+      </p:sp>
+      <p:cxnSp>
+        <p:nvCxnSpPr>
+          <p:cNvPr id="166" name="Straight Arrow Connector 165">
+            <a:extLst>
+              <a:ext uri="{FF2B5EF4-FFF2-40B4-BE49-F238E27FC236}">
+                <a16:creationId xmlns:a16="http://schemas.microsoft.com/office/drawing/2014/main" id="{5C17D29A-B579-A486-96FC-78ABDBD1C8C3}"/>
+              </a:ext>
+            </a:extLst>
+          </p:cNvPr>
+          <p:cNvCxnSpPr>
+            <a:cxnSpLocks/>
+          </p:cNvCxnSpPr>
+          <p:nvPr/>
+        </p:nvCxnSpPr>
+        <p:spPr>
+          <a:xfrm>
+            <a:off x="6532999" y="3739661"/>
+            <a:ext cx="380040" cy="0"/>
+          </a:xfrm>
+          <a:prstGeom prst="straightConnector1">
+            <a:avLst/>
+          </a:prstGeom>
+          <a:ln w="19050" cap="flat" cmpd="sng" algn="ctr">
+            <a:solidFill>
+              <a:schemeClr val="accent3"/>
+            </a:solidFill>
+            <a:prstDash val="solid"/>
+            <a:round/>
+            <a:headEnd type="none" w="med" len="med"/>
+            <a:tailEnd type="arrow" w="med" len="med"/>
+          </a:ln>
+        </p:spPr>
+        <p:style>
+          <a:lnRef idx="0">
+            <a:scrgbClr r="0" g="0" b="0"/>
+          </a:lnRef>
+          <a:fillRef idx="0">
+            <a:scrgbClr r="0" g="0" b="0"/>
+          </a:fillRef>
+          <a:effectRef idx="0">
+            <a:scrgbClr r="0" g="0" b="0"/>
+          </a:effectRef>
+          <a:fontRef idx="minor">
+            <a:schemeClr val="tx1"/>
+          </a:fontRef>
+        </p:style>
+      </p:cxnSp>
+      <p:pic>
+        <p:nvPicPr>
+          <p:cNvPr id="1026" name="Picture 2" descr="Gear Icon Images – Browse 1,547,415 Stock Photos, Vectors ...">
+            <a:extLst>
+              <a:ext uri="{FF2B5EF4-FFF2-40B4-BE49-F238E27FC236}">
+                <a16:creationId xmlns:a16="http://schemas.microsoft.com/office/drawing/2014/main" id="{1AECB0A3-77BC-66E6-2B68-47C34414435E}"/>
+              </a:ext>
+            </a:extLst>
+          </p:cNvPr>
+          <p:cNvPicPr>
+            <a:picLocks noChangeAspect="1" noChangeArrowheads="1"/>
+          </p:cNvPicPr>
+          <p:nvPr/>
+        </p:nvPicPr>
+        <p:blipFill>
+          <a:blip r:embed="rId5">
+            <a:extLst>
+              <a:ext uri="{28A0092B-C50C-407E-A947-70E740481C1C}">
+                <a14:useLocalDpi xmlns:a14="http://schemas.microsoft.com/office/drawing/2010/main" val="0"/>
+              </a:ext>
+            </a:extLst>
+          </a:blip>
+          <a:srcRect/>
+          <a:stretch>
+            <a:fillRect/>
+          </a:stretch>
+        </p:blipFill>
+        <p:spPr bwMode="auto">
+          <a:xfrm>
+            <a:off x="5532104" y="3222872"/>
+            <a:ext cx="267741" cy="267741"/>
+          </a:xfrm>
+          <a:prstGeom prst="rect">
+            <a:avLst/>
+          </a:prstGeom>
+          <a:noFill/>
+          <a:extLst>
+            <a:ext uri="{909E8E84-426E-40DD-AFC4-6F175D3DCCD1}">
+              <a14:hiddenFill xmlns:a14="http://schemas.microsoft.com/office/drawing/2010/main">
+                <a:solidFill>
+                  <a:srgbClr val="FFFFFF"/>
+                </a:solidFill>
+              </a14:hiddenFill>
+            </a:ext>
+          </a:extLst>
+        </p:spPr>
+      </p:pic>
+      <p:sp>
+        <p:nvSpPr>
+          <p:cNvPr id="3" name="TextBox 2">
+            <a:extLst>
+              <a:ext uri="{FF2B5EF4-FFF2-40B4-BE49-F238E27FC236}">
+                <a16:creationId xmlns:a16="http://schemas.microsoft.com/office/drawing/2014/main" id="{07143970-893A-DC63-B472-1AF91A9C6CFA}"/>
+              </a:ext>
+            </a:extLst>
+          </p:cNvPr>
+          <p:cNvSpPr txBox="1"/>
+          <p:nvPr/>
+        </p:nvSpPr>
+        <p:spPr>
+          <a:xfrm>
+            <a:off x="5001999" y="3213556"/>
+            <a:ext cx="471603" cy="215444"/>
+          </a:xfrm>
+          <a:prstGeom prst="rect">
+            <a:avLst/>
+          </a:prstGeom>
+          <a:noFill/>
+        </p:spPr>
+        <p:txBody>
+          <a:bodyPr wrap="none" rtlCol="0">
+            <a:spAutoFit/>
+          </a:bodyPr>
+          <a:lstStyle/>
+          <a:p>
+            <a:r>
+              <a:rPr lang="en-US" sz="800" dirty="0">
+                <a:latin typeface="Verdana" panose="020B0604030504040204" pitchFamily="34" charset="0"/>
+                <a:ea typeface="Verdana" panose="020B0604030504040204" pitchFamily="34" charset="0"/>
+              </a:rPr>
+              <a:t>Temp</a:t>
+            </a:r>
+          </a:p>
+        </p:txBody>
+      </p:sp>
+      <p:sp>
+        <p:nvSpPr>
+          <p:cNvPr id="4" name="TextBox 3">
+            <a:extLst>
+              <a:ext uri="{FF2B5EF4-FFF2-40B4-BE49-F238E27FC236}">
+                <a16:creationId xmlns:a16="http://schemas.microsoft.com/office/drawing/2014/main" id="{A7BD0719-6936-4181-1582-39240C2BE1CF}"/>
+              </a:ext>
+            </a:extLst>
+          </p:cNvPr>
+          <p:cNvSpPr txBox="1"/>
+          <p:nvPr/>
+        </p:nvSpPr>
+        <p:spPr>
+          <a:xfrm rot="3268670">
+            <a:off x="5186235" y="2997322"/>
+            <a:ext cx="473206" cy="215444"/>
+          </a:xfrm>
+          <a:prstGeom prst="rect">
+            <a:avLst/>
+          </a:prstGeom>
+          <a:noFill/>
+        </p:spPr>
+        <p:txBody>
+          <a:bodyPr wrap="none" rtlCol="0">
+            <a:spAutoFit/>
+          </a:bodyPr>
+          <a:lstStyle/>
+          <a:p>
+            <a:pPr algn="r"/>
+            <a:r>
+              <a:rPr lang="en-US" sz="800" dirty="0">
+                <a:latin typeface="Verdana" panose="020B0604030504040204" pitchFamily="34" charset="0"/>
+                <a:ea typeface="Verdana" panose="020B0604030504040204" pitchFamily="34" charset="0"/>
+              </a:rPr>
+              <a:t>Top P</a:t>
+            </a:r>
+          </a:p>
+        </p:txBody>
+      </p:sp>
+      <p:sp>
+        <p:nvSpPr>
+          <p:cNvPr id="5" name="TextBox 4">
+            <a:extLst>
+              <a:ext uri="{FF2B5EF4-FFF2-40B4-BE49-F238E27FC236}">
+                <a16:creationId xmlns:a16="http://schemas.microsoft.com/office/drawing/2014/main" id="{EA93EA8B-9F21-03A5-8C88-73F69F622485}"/>
+              </a:ext>
+            </a:extLst>
+          </p:cNvPr>
+          <p:cNvSpPr txBox="1"/>
+          <p:nvPr/>
+        </p:nvSpPr>
+        <p:spPr>
+          <a:xfrm rot="5400000">
+            <a:off x="5433520" y="2949812"/>
+            <a:ext cx="481222" cy="215444"/>
+          </a:xfrm>
+          <a:prstGeom prst="rect">
+            <a:avLst/>
+          </a:prstGeom>
+          <a:noFill/>
+        </p:spPr>
+        <p:txBody>
+          <a:bodyPr wrap="none" rtlCol="0">
+            <a:spAutoFit/>
+          </a:bodyPr>
+          <a:lstStyle/>
+          <a:p>
+            <a:pPr algn="ctr"/>
+            <a:r>
+              <a:rPr lang="en-US" sz="800" dirty="0">
+                <a:latin typeface="Verdana" panose="020B0604030504040204" pitchFamily="34" charset="0"/>
+                <a:ea typeface="Verdana" panose="020B0604030504040204" pitchFamily="34" charset="0"/>
+              </a:rPr>
+              <a:t>Top K</a:t>
+            </a:r>
+          </a:p>
+        </p:txBody>
+      </p:sp>
+      <p:sp>
+        <p:nvSpPr>
+          <p:cNvPr id="2" name="Rectangle 1">
+            <a:extLst>
+              <a:ext uri="{FF2B5EF4-FFF2-40B4-BE49-F238E27FC236}">
+                <a16:creationId xmlns:a16="http://schemas.microsoft.com/office/drawing/2014/main" id="{55D402E2-C131-C549-CC2C-D65D07D6961A}"/>
+              </a:ext>
+            </a:extLst>
+          </p:cNvPr>
+          <p:cNvSpPr/>
+          <p:nvPr/>
+        </p:nvSpPr>
+        <p:spPr>
+          <a:xfrm>
+            <a:off x="5935023" y="1579114"/>
+            <a:ext cx="1583378" cy="983351"/>
+          </a:xfrm>
+          <a:prstGeom prst="rect">
+            <a:avLst/>
+          </a:prstGeom>
+          <a:noFill/>
+          <a:ln w="12700" cap="flat" cmpd="sng" algn="ctr">
+            <a:solidFill>
+              <a:srgbClr val="C4232A">
+                <a:lumMod val="60000"/>
+                <a:lumOff val="40000"/>
+              </a:srgbClr>
+            </a:solidFill>
+            <a:prstDash val="dash"/>
+            <a:miter lim="800000"/>
+          </a:ln>
+          <a:effectLst/>
+        </p:spPr>
+        <p:txBody>
+          <a:bodyPr rtlCol="0" anchor="ctr"/>
+          <a:lstStyle/>
+          <a:p>
+            <a:pPr marL="0" marR="0" lvl="0" indent="0" algn="ctr" defTabSz="914400" eaLnBrk="1" fontAlgn="auto" latinLnBrk="0" hangingPunct="1">
+              <a:lnSpc>
+                <a:spcPct val="100000"/>
+              </a:lnSpc>
+              <a:spcBef>
+                <a:spcPts val="0"/>
+              </a:spcBef>
+              <a:spcAft>
+                <a:spcPts val="0"/>
+              </a:spcAft>
+              <a:buClrTx/>
+              <a:buSzTx/>
+              <a:buFontTx/>
+              <a:buNone/>
+              <a:tabLst/>
+              <a:defRPr/>
+            </a:pPr>
+            <a:endParaRPr kumimoji="0" lang="nl-NL" sz="1800" b="0" i="0" u="none" strike="noStrike" kern="0" cap="none" spc="0" normalizeH="0" baseline="0" noProof="0">
+              <a:ln>
+                <a:noFill/>
+              </a:ln>
+              <a:solidFill>
+                <a:prstClr val="white"/>
+              </a:solidFill>
+              <a:effectLst/>
+              <a:uLnTx/>
+              <a:uFillTx/>
+              <a:latin typeface="Segoe UI Light"/>
+              <a:ea typeface="+mn-ea"/>
+              <a:cs typeface="+mn-cs"/>
+            </a:endParaRPr>
+          </a:p>
+        </p:txBody>
+      </p:sp>
+      <p:sp>
+        <p:nvSpPr>
+          <p:cNvPr id="9" name="Rectangle: Rounded Corners 8">
+            <a:extLst>
+              <a:ext uri="{FF2B5EF4-FFF2-40B4-BE49-F238E27FC236}">
+                <a16:creationId xmlns:a16="http://schemas.microsoft.com/office/drawing/2014/main" id="{CE14E054-E291-C6E8-6457-09AC473102DB}"/>
+              </a:ext>
+            </a:extLst>
+          </p:cNvPr>
+          <p:cNvSpPr/>
+          <p:nvPr/>
+        </p:nvSpPr>
+        <p:spPr>
+          <a:xfrm>
+            <a:off x="6014999" y="1767530"/>
+            <a:ext cx="1279585" cy="548639"/>
+          </a:xfrm>
+          <a:prstGeom prst="roundRect">
+            <a:avLst/>
+          </a:prstGeom>
+          <a:solidFill>
+            <a:srgbClr val="FFC000">
+              <a:alpha val="24000"/>
+            </a:srgbClr>
+          </a:solidFill>
+          <a:ln w="12700" cap="flat" cmpd="sng" algn="ctr">
+            <a:solidFill>
+              <a:srgbClr val="3C9BD5">
+                <a:shade val="15000"/>
+              </a:srgbClr>
+            </a:solidFill>
+            <a:prstDash val="solid"/>
+            <a:miter lim="800000"/>
+          </a:ln>
+          <a:effectLst/>
+        </p:spPr>
+        <p:txBody>
+          <a:bodyPr rtlCol="0" anchor="ctr"/>
+          <a:lstStyle/>
+          <a:p>
+            <a:pPr marL="0" marR="0" lvl="0" indent="0" algn="ctr" defTabSz="914400" eaLnBrk="1" fontAlgn="auto" latinLnBrk="0" hangingPunct="1">
+              <a:lnSpc>
+                <a:spcPct val="100000"/>
+              </a:lnSpc>
+              <a:spcBef>
+                <a:spcPts val="0"/>
+              </a:spcBef>
+              <a:spcAft>
+                <a:spcPts val="0"/>
+              </a:spcAft>
+              <a:buClrTx/>
+              <a:buSzTx/>
+              <a:buFontTx/>
+              <a:buNone/>
+              <a:tabLst/>
+              <a:defRPr/>
+            </a:pPr>
+            <a:endParaRPr kumimoji="0" lang="nl-NL" sz="1800" b="0" i="0" u="none" strike="noStrike" kern="0" cap="none" spc="0" normalizeH="0" baseline="0" noProof="0">
+              <a:ln>
+                <a:noFill/>
+              </a:ln>
+              <a:solidFill>
+                <a:prstClr val="white"/>
+              </a:solidFill>
+              <a:effectLst/>
+              <a:uLnTx/>
+              <a:uFillTx/>
+              <a:latin typeface="Segoe UI Light"/>
+              <a:ea typeface="+mn-ea"/>
+              <a:cs typeface="+mn-cs"/>
+            </a:endParaRPr>
+          </a:p>
+        </p:txBody>
+      </p:sp>
+      <p:pic>
+        <p:nvPicPr>
+          <p:cNvPr id="12" name="Picture 11">
+            <a:extLst>
+              <a:ext uri="{FF2B5EF4-FFF2-40B4-BE49-F238E27FC236}">
+                <a16:creationId xmlns:a16="http://schemas.microsoft.com/office/drawing/2014/main" id="{7AC2BBA1-E50F-77AE-E512-A7D976B2AA49}"/>
+              </a:ext>
+            </a:extLst>
+          </p:cNvPr>
+          <p:cNvPicPr>
+            <a:picLocks noChangeAspect="1"/>
+          </p:cNvPicPr>
+          <p:nvPr/>
+        </p:nvPicPr>
+        <p:blipFill>
+          <a:blip r:embed="rId6">
+            <a:clrChange>
+              <a:clrFrom>
+                <a:srgbClr val="F4F4F6"/>
+              </a:clrFrom>
+              <a:clrTo>
+                <a:srgbClr val="F4F4F6">
+                  <a:alpha val="0"/>
+                </a:srgbClr>
+              </a:clrTo>
+            </a:clrChange>
+          </a:blip>
+          <a:stretch>
+            <a:fillRect/>
+          </a:stretch>
+        </p:blipFill>
+        <p:spPr>
+          <a:xfrm>
+            <a:off x="6090218" y="1851960"/>
+            <a:ext cx="366849" cy="404445"/>
+          </a:xfrm>
+          <a:prstGeom prst="rect">
+            <a:avLst/>
+          </a:prstGeom>
+        </p:spPr>
+      </p:pic>
+      <p:cxnSp>
+        <p:nvCxnSpPr>
+          <p:cNvPr id="15" name="Straight Arrow Connector 14">
+            <a:extLst>
+              <a:ext uri="{FF2B5EF4-FFF2-40B4-BE49-F238E27FC236}">
+                <a16:creationId xmlns:a16="http://schemas.microsoft.com/office/drawing/2014/main" id="{26D61310-7AF7-FE94-8BE0-71109D836C84}"/>
+              </a:ext>
+            </a:extLst>
+          </p:cNvPr>
+          <p:cNvCxnSpPr/>
+          <p:nvPr/>
+        </p:nvCxnSpPr>
+        <p:spPr>
+          <a:xfrm>
+            <a:off x="6085340" y="2684787"/>
+            <a:ext cx="0" cy="504000"/>
+          </a:xfrm>
+          <a:prstGeom prst="straightConnector1">
+            <a:avLst/>
+          </a:prstGeom>
+          <a:ln w="19050" cap="flat" cmpd="sng" algn="ctr">
+            <a:solidFill>
+              <a:schemeClr val="accent3"/>
+            </a:solidFill>
+            <a:prstDash val="solid"/>
+            <a:round/>
+            <a:headEnd type="none" w="med" len="med"/>
+            <a:tailEnd type="arrow" w="med" len="med"/>
+          </a:ln>
+        </p:spPr>
+        <p:style>
+          <a:lnRef idx="0">
+            <a:scrgbClr r="0" g="0" b="0"/>
+          </a:lnRef>
+          <a:fillRef idx="0">
+            <a:scrgbClr r="0" g="0" b="0"/>
+          </a:fillRef>
+          <a:effectRef idx="0">
+            <a:scrgbClr r="0" g="0" b="0"/>
+          </a:effectRef>
+          <a:fontRef idx="minor">
+            <a:schemeClr val="tx1"/>
+          </a:fontRef>
+        </p:style>
+      </p:cxnSp>
+      <p:pic>
+        <p:nvPicPr>
+          <p:cNvPr id="21" name="Picture 20">
+            <a:extLst>
+              <a:ext uri="{FF2B5EF4-FFF2-40B4-BE49-F238E27FC236}">
+                <a16:creationId xmlns:a16="http://schemas.microsoft.com/office/drawing/2014/main" id="{0930579D-C566-862B-C133-CE51C8ECFF3A}"/>
+              </a:ext>
+            </a:extLst>
+          </p:cNvPr>
+          <p:cNvPicPr>
+            <a:picLocks noChangeAspect="1"/>
+          </p:cNvPicPr>
+          <p:nvPr/>
+        </p:nvPicPr>
+        <p:blipFill>
+          <a:blip r:embed="rId7">
+            <a:clrChange>
+              <a:clrFrom>
+                <a:srgbClr val="F4F4F6"/>
+              </a:clrFrom>
+              <a:clrTo>
+                <a:srgbClr val="F4F4F6">
+                  <a:alpha val="0"/>
+                </a:srgbClr>
+              </a:clrTo>
+            </a:clrChange>
+          </a:blip>
+          <a:stretch>
+            <a:fillRect/>
+          </a:stretch>
+        </p:blipFill>
+        <p:spPr>
+          <a:xfrm>
+            <a:off x="6185787" y="2639445"/>
+            <a:ext cx="694423" cy="611897"/>
+          </a:xfrm>
+          <a:prstGeom prst="rect">
+            <a:avLst/>
+          </a:prstGeom>
+        </p:spPr>
+      </p:pic>
+      <p:sp>
+        <p:nvSpPr>
+          <p:cNvPr id="22" name="TextBox 21">
+            <a:extLst>
+              <a:ext uri="{FF2B5EF4-FFF2-40B4-BE49-F238E27FC236}">
+                <a16:creationId xmlns:a16="http://schemas.microsoft.com/office/drawing/2014/main" id="{DD257119-8E76-1076-C58F-1DE57AE597E1}"/>
+              </a:ext>
+            </a:extLst>
+          </p:cNvPr>
+          <p:cNvSpPr txBox="1"/>
+          <p:nvPr/>
+        </p:nvSpPr>
+        <p:spPr>
+          <a:xfrm>
+            <a:off x="6792926" y="2753514"/>
+            <a:ext cx="678391" cy="338554"/>
+          </a:xfrm>
+          <a:prstGeom prst="rect">
+            <a:avLst/>
+          </a:prstGeom>
+          <a:noFill/>
+        </p:spPr>
+        <p:txBody>
+          <a:bodyPr wrap="none" rtlCol="0">
+            <a:spAutoFit/>
+          </a:bodyPr>
+          <a:lstStyle/>
+          <a:p>
+            <a:pPr marL="0" marR="0" lvl="0" indent="0" defTabSz="914400" eaLnBrk="1" fontAlgn="auto" latinLnBrk="0" hangingPunct="1">
+              <a:lnSpc>
+                <a:spcPct val="100000"/>
+              </a:lnSpc>
+              <a:spcBef>
+                <a:spcPts val="0"/>
+              </a:spcBef>
+              <a:spcAft>
+                <a:spcPts val="0"/>
+              </a:spcAft>
+              <a:buClrTx/>
+              <a:buSzTx/>
+              <a:buFontTx/>
+              <a:buNone/>
+              <a:tabLst/>
+              <a:defRPr/>
+            </a:pPr>
+            <a:r>
+              <a:rPr lang="en-US" sz="800" kern="0" dirty="0">
+                <a:solidFill>
+                  <a:prstClr val="black"/>
+                </a:solidFill>
+                <a:latin typeface="Verdana" panose="020B0604030504040204" pitchFamily="34" charset="0"/>
+                <a:ea typeface="Verdana" panose="020B0604030504040204" pitchFamily="34" charset="0"/>
+              </a:rPr>
+              <a:t>Optimize </a:t>
+            </a:r>
+          </a:p>
+          <a:p>
+            <a:pPr marL="0" marR="0" lvl="0" indent="0" defTabSz="914400" eaLnBrk="1" fontAlgn="auto" latinLnBrk="0" hangingPunct="1">
+              <a:lnSpc>
+                <a:spcPct val="100000"/>
+              </a:lnSpc>
+              <a:spcBef>
+                <a:spcPts val="0"/>
+              </a:spcBef>
+              <a:spcAft>
+                <a:spcPts val="0"/>
+              </a:spcAft>
+              <a:buClrTx/>
+              <a:buSzTx/>
+              <a:buFontTx/>
+              <a:buNone/>
+              <a:tabLst/>
+              <a:defRPr/>
+            </a:pPr>
+            <a:r>
+              <a:rPr lang="en-US" sz="800" kern="0" dirty="0">
+                <a:solidFill>
+                  <a:prstClr val="black"/>
+                </a:solidFill>
+                <a:latin typeface="Verdana" panose="020B0604030504040204" pitchFamily="34" charset="0"/>
+                <a:ea typeface="Verdana" panose="020B0604030504040204" pitchFamily="34" charset="0"/>
+              </a:rPr>
+              <a:t>Prompt</a:t>
+            </a:r>
+            <a:endParaRPr kumimoji="0" lang="nl-NL" sz="800" b="0" i="0" u="none" strike="noStrike" kern="0" cap="none" spc="0" normalizeH="0" baseline="0" noProof="0" dirty="0" err="1">
+              <a:ln>
+                <a:noFill/>
+              </a:ln>
+              <a:solidFill>
+                <a:prstClr val="black"/>
+              </a:solidFill>
+              <a:effectLst/>
+              <a:uLnTx/>
+              <a:uFillTx/>
+              <a:latin typeface="Verdana" panose="020B0604030504040204" pitchFamily="34" charset="0"/>
+              <a:ea typeface="Verdana" panose="020B0604030504040204" pitchFamily="34" charset="0"/>
+            </a:endParaRPr>
+          </a:p>
+        </p:txBody>
+      </p:sp>
+      <p:sp>
+        <p:nvSpPr>
+          <p:cNvPr id="23" name="TextBox 22">
+            <a:extLst>
+              <a:ext uri="{FF2B5EF4-FFF2-40B4-BE49-F238E27FC236}">
+                <a16:creationId xmlns:a16="http://schemas.microsoft.com/office/drawing/2014/main" id="{38ABEC97-B079-F5C5-31AC-FB52D373ADFC}"/>
+              </a:ext>
+            </a:extLst>
+          </p:cNvPr>
+          <p:cNvSpPr txBox="1"/>
+          <p:nvPr/>
+        </p:nvSpPr>
+        <p:spPr>
+          <a:xfrm>
+            <a:off x="5935023" y="1345494"/>
+            <a:ext cx="1583378" cy="246221"/>
+          </a:xfrm>
+          <a:prstGeom prst="rect">
+            <a:avLst/>
+          </a:prstGeom>
+          <a:noFill/>
+        </p:spPr>
+        <p:txBody>
+          <a:bodyPr wrap="square" rtlCol="0">
+            <a:spAutoFit/>
+          </a:bodyPr>
+          <a:lstStyle/>
+          <a:p>
+            <a:pPr algn="ctr"/>
+            <a:r>
+              <a:rPr lang="en-US" sz="1000" b="1" dirty="0">
+                <a:solidFill>
+                  <a:prstClr val="black"/>
+                </a:solidFill>
+                <a:latin typeface="Verdana" panose="020B0604030504040204" pitchFamily="34" charset="0"/>
+                <a:ea typeface="Verdana" panose="020B0604030504040204" pitchFamily="34" charset="0"/>
+              </a:rPr>
+              <a:t>Synthesis</a:t>
+            </a:r>
+            <a:endParaRPr lang="nl-NL" sz="1000" b="1" dirty="0" err="1">
+              <a:solidFill>
+                <a:prstClr val="black"/>
+              </a:solidFill>
+              <a:latin typeface="Verdana" panose="020B0604030504040204" pitchFamily="34" charset="0"/>
+              <a:ea typeface="Verdana" panose="020B0604030504040204" pitchFamily="34" charset="0"/>
+            </a:endParaRPr>
+          </a:p>
+        </p:txBody>
+      </p:sp>
+      <p:sp>
+        <p:nvSpPr>
+          <p:cNvPr id="24" name="TextBox 23">
+            <a:extLst>
+              <a:ext uri="{FF2B5EF4-FFF2-40B4-BE49-F238E27FC236}">
+                <a16:creationId xmlns:a16="http://schemas.microsoft.com/office/drawing/2014/main" id="{11E2D11D-110B-D6D0-B97D-2C06468FD6EA}"/>
+              </a:ext>
+            </a:extLst>
+          </p:cNvPr>
+          <p:cNvSpPr txBox="1"/>
+          <p:nvPr/>
+        </p:nvSpPr>
+        <p:spPr>
+          <a:xfrm>
+            <a:off x="2418237" y="2344370"/>
+            <a:ext cx="1944763" cy="215444"/>
+          </a:xfrm>
+          <a:prstGeom prst="rect">
+            <a:avLst/>
+          </a:prstGeom>
+          <a:noFill/>
+        </p:spPr>
+        <p:txBody>
+          <a:bodyPr wrap="none" rtlCol="0">
+            <a:spAutoFit/>
+          </a:bodyPr>
+          <a:lstStyle/>
+          <a:p>
+            <a:pPr marL="0" marR="0" lvl="0" indent="0" defTabSz="914400" eaLnBrk="1" fontAlgn="auto" latinLnBrk="0" hangingPunct="1">
+              <a:lnSpc>
+                <a:spcPct val="100000"/>
+              </a:lnSpc>
+              <a:spcBef>
+                <a:spcPts val="0"/>
+              </a:spcBef>
+              <a:spcAft>
+                <a:spcPts val="0"/>
+              </a:spcAft>
+              <a:buClrTx/>
+              <a:buSzTx/>
+              <a:buFontTx/>
+              <a:buNone/>
+              <a:tabLst/>
+              <a:defRPr/>
+            </a:pPr>
+            <a:r>
+              <a:rPr kumimoji="0" lang="en-US" sz="800" b="0" i="0" u="none" strike="noStrike" kern="0" cap="none" spc="0" normalizeH="0" baseline="0" noProof="0" dirty="0">
+                <a:ln>
+                  <a:noFill/>
+                </a:ln>
+                <a:solidFill>
+                  <a:prstClr val="black"/>
+                </a:solidFill>
+                <a:effectLst/>
+                <a:uLnTx/>
+                <a:uFillTx/>
+                <a:latin typeface="Verdana" panose="020B0604030504040204" pitchFamily="34" charset="0"/>
+                <a:ea typeface="Verdana" panose="020B0604030504040204" pitchFamily="34" charset="0"/>
+              </a:rPr>
+              <a:t>(Select context and Build prompt)</a:t>
+            </a:r>
+            <a:endParaRPr kumimoji="0" lang="nl-NL" sz="800" b="0" i="0" u="none" strike="noStrike" kern="0" cap="none" spc="0" normalizeH="0" baseline="0" noProof="0" dirty="0" err="1">
+              <a:ln>
+                <a:noFill/>
+              </a:ln>
+              <a:solidFill>
+                <a:prstClr val="black"/>
+              </a:solidFill>
+              <a:effectLst/>
+              <a:uLnTx/>
+              <a:uFillTx/>
+              <a:latin typeface="Verdana" panose="020B0604030504040204" pitchFamily="34" charset="0"/>
+              <a:ea typeface="Verdana" panose="020B0604030504040204" pitchFamily="34" charset="0"/>
+            </a:endParaRPr>
+          </a:p>
+        </p:txBody>
+      </p:sp>
+      <p:sp>
+        <p:nvSpPr>
+          <p:cNvPr id="25" name="TextBox 24">
+            <a:extLst>
+              <a:ext uri="{FF2B5EF4-FFF2-40B4-BE49-F238E27FC236}">
+                <a16:creationId xmlns:a16="http://schemas.microsoft.com/office/drawing/2014/main" id="{115339E1-09CC-DD16-22F5-C721566B75D9}"/>
+              </a:ext>
+            </a:extLst>
+          </p:cNvPr>
+          <p:cNvSpPr txBox="1"/>
+          <p:nvPr/>
+        </p:nvSpPr>
+        <p:spPr>
+          <a:xfrm>
+            <a:off x="4553562" y="2327797"/>
+            <a:ext cx="965329" cy="215444"/>
+          </a:xfrm>
+          <a:prstGeom prst="rect">
+            <a:avLst/>
+          </a:prstGeom>
+          <a:noFill/>
+        </p:spPr>
+        <p:txBody>
+          <a:bodyPr wrap="none" rtlCol="0">
+            <a:spAutoFit/>
+          </a:bodyPr>
+          <a:lstStyle/>
+          <a:p>
+            <a:pPr marL="0" marR="0" lvl="0" indent="0" defTabSz="914400" eaLnBrk="1" fontAlgn="auto" latinLnBrk="0" hangingPunct="1">
+              <a:lnSpc>
+                <a:spcPct val="100000"/>
+              </a:lnSpc>
+              <a:spcBef>
+                <a:spcPts val="0"/>
+              </a:spcBef>
+              <a:spcAft>
+                <a:spcPts val="0"/>
+              </a:spcAft>
+              <a:buClrTx/>
+              <a:buSzTx/>
+              <a:buFontTx/>
+              <a:buNone/>
+              <a:tabLst/>
+              <a:defRPr/>
+            </a:pPr>
+            <a:r>
+              <a:rPr kumimoji="0" lang="en-US" sz="800" b="0" i="0" u="none" strike="noStrike" kern="0" cap="none" spc="0" normalizeH="0" baseline="0" noProof="0" dirty="0">
+                <a:ln>
+                  <a:noFill/>
+                </a:ln>
+                <a:solidFill>
+                  <a:prstClr val="black"/>
+                </a:solidFill>
+                <a:effectLst/>
+                <a:uLnTx/>
+                <a:uFillTx/>
+                <a:latin typeface="Verdana" panose="020B0604030504040204" pitchFamily="34" charset="0"/>
+                <a:ea typeface="Verdana" panose="020B0604030504040204" pitchFamily="34" charset="0"/>
+              </a:rPr>
+              <a:t>(Store Results)</a:t>
+            </a:r>
+            <a:endParaRPr kumimoji="0" lang="nl-NL" sz="800" b="0" i="0" u="none" strike="noStrike" kern="0" cap="none" spc="0" normalizeH="0" baseline="0" noProof="0" dirty="0" err="1">
+              <a:ln>
+                <a:noFill/>
+              </a:ln>
+              <a:solidFill>
+                <a:prstClr val="black"/>
+              </a:solidFill>
+              <a:effectLst/>
+              <a:uLnTx/>
+              <a:uFillTx/>
+              <a:latin typeface="Verdana" panose="020B0604030504040204" pitchFamily="34" charset="0"/>
+              <a:ea typeface="Verdana" panose="020B0604030504040204" pitchFamily="34" charset="0"/>
+            </a:endParaRPr>
+          </a:p>
+        </p:txBody>
+      </p:sp>
+      <p:sp>
+        <p:nvSpPr>
+          <p:cNvPr id="11" name="TextBox 10">
+            <a:extLst>
+              <a:ext uri="{FF2B5EF4-FFF2-40B4-BE49-F238E27FC236}">
+                <a16:creationId xmlns:a16="http://schemas.microsoft.com/office/drawing/2014/main" id="{3BE61575-4C1B-D681-BFBE-2245974F11BE}"/>
+              </a:ext>
+            </a:extLst>
+          </p:cNvPr>
+          <p:cNvSpPr txBox="1"/>
+          <p:nvPr/>
+        </p:nvSpPr>
+        <p:spPr>
+          <a:xfrm>
+            <a:off x="6380135" y="1858725"/>
+            <a:ext cx="1001224" cy="338554"/>
+          </a:xfrm>
+          <a:prstGeom prst="rect">
+            <a:avLst/>
+          </a:prstGeom>
+          <a:noFill/>
+        </p:spPr>
+        <p:txBody>
+          <a:bodyPr wrap="square" rtlCol="0">
+            <a:spAutoFit/>
+          </a:bodyPr>
+          <a:lstStyle/>
+          <a:p>
+            <a:pPr lvl="0">
+              <a:defRPr/>
+            </a:pPr>
+            <a:r>
+              <a:rPr lang="en-US" sz="800" kern="0" dirty="0">
+                <a:solidFill>
+                  <a:prstClr val="black"/>
+                </a:solidFill>
+                <a:latin typeface="Verdana" panose="020B0604030504040204" pitchFamily="34" charset="0"/>
+                <a:ea typeface="Verdana" panose="020B0604030504040204" pitchFamily="34" charset="0"/>
+              </a:rPr>
+              <a:t>- Merge results</a:t>
+            </a:r>
+          </a:p>
+          <a:p>
+            <a:pPr lvl="0">
+              <a:defRPr/>
+            </a:pPr>
+            <a:r>
+              <a:rPr kumimoji="0" lang="nl-NL" sz="800" b="0" i="0" u="none" strike="noStrike" kern="0" cap="none" spc="0" normalizeH="0" baseline="0" noProof="0" dirty="0">
+                <a:ln>
+                  <a:noFill/>
+                </a:ln>
+                <a:solidFill>
+                  <a:prstClr val="black"/>
+                </a:solidFill>
+                <a:effectLst/>
+                <a:uLnTx/>
+                <a:uFillTx/>
+                <a:latin typeface="Verdana" panose="020B0604030504040204" pitchFamily="34" charset="0"/>
+                <a:ea typeface="Verdana" panose="020B0604030504040204" pitchFamily="34" charset="0"/>
+              </a:rPr>
+              <a:t>- Build prompt</a:t>
+            </a:r>
+          </a:p>
+        </p:txBody>
+      </p:sp>
+      <p:sp>
+        <p:nvSpPr>
+          <p:cNvPr id="27" name="TextBox 26">
+            <a:extLst>
+              <a:ext uri="{FF2B5EF4-FFF2-40B4-BE49-F238E27FC236}">
+                <a16:creationId xmlns:a16="http://schemas.microsoft.com/office/drawing/2014/main" id="{FE0FB4D6-2B91-77C8-FCC9-F2742F89C6D4}"/>
+              </a:ext>
+            </a:extLst>
+          </p:cNvPr>
+          <p:cNvSpPr txBox="1"/>
+          <p:nvPr/>
+        </p:nvSpPr>
+        <p:spPr>
+          <a:xfrm>
+            <a:off x="3552967" y="2721337"/>
+            <a:ext cx="1000595" cy="246221"/>
+          </a:xfrm>
+          <a:prstGeom prst="rect">
+            <a:avLst/>
+          </a:prstGeom>
+          <a:noFill/>
+        </p:spPr>
+        <p:txBody>
+          <a:bodyPr wrap="none" rtlCol="0">
+            <a:spAutoFit/>
+          </a:bodyPr>
+          <a:lstStyle/>
+          <a:p>
+            <a:r>
+              <a:rPr lang="en-US" sz="1000" b="1" dirty="0">
+                <a:solidFill>
+                  <a:prstClr val="black"/>
+                </a:solidFill>
+                <a:latin typeface="Verdana" panose="020B0604030504040204" pitchFamily="34" charset="0"/>
+                <a:ea typeface="Verdana" panose="020B0604030504040204" pitchFamily="34" charset="0"/>
+              </a:rPr>
+              <a:t>New Chunk</a:t>
+            </a:r>
+            <a:endParaRPr lang="nl-NL" sz="1000" b="1" dirty="0" err="1">
+              <a:solidFill>
+                <a:prstClr val="black"/>
+              </a:solidFill>
+              <a:latin typeface="Verdana" panose="020B0604030504040204" pitchFamily="34" charset="0"/>
+              <a:ea typeface="Verdana" panose="020B0604030504040204" pitchFamily="34" charset="0"/>
+            </a:endParaRPr>
+          </a:p>
+        </p:txBody>
+      </p:sp>
+      <p:sp>
+        <p:nvSpPr>
+          <p:cNvPr id="29" name="TextBox 28">
+            <a:extLst>
+              <a:ext uri="{FF2B5EF4-FFF2-40B4-BE49-F238E27FC236}">
+                <a16:creationId xmlns:a16="http://schemas.microsoft.com/office/drawing/2014/main" id="{320F9636-110B-74FF-2C84-D2767FBF9410}"/>
+              </a:ext>
+            </a:extLst>
+          </p:cNvPr>
+          <p:cNvSpPr txBox="1"/>
+          <p:nvPr/>
+        </p:nvSpPr>
+        <p:spPr>
+          <a:xfrm>
+            <a:off x="2581732" y="4091057"/>
+            <a:ext cx="1519968" cy="246221"/>
+          </a:xfrm>
+          <a:prstGeom prst="rect">
+            <a:avLst/>
+          </a:prstGeom>
+          <a:noFill/>
+        </p:spPr>
+        <p:txBody>
+          <a:bodyPr wrap="none" rtlCol="0">
+            <a:spAutoFit/>
+          </a:bodyPr>
+          <a:lstStyle/>
+          <a:p>
+            <a:r>
+              <a:rPr lang="en-US" sz="1000" b="1" dirty="0">
+                <a:solidFill>
+                  <a:prstClr val="black"/>
+                </a:solidFill>
+                <a:latin typeface="Verdana" panose="020B0604030504040204" pitchFamily="34" charset="0"/>
+                <a:ea typeface="Verdana" panose="020B0604030504040204" pitchFamily="34" charset="0"/>
+              </a:rPr>
+              <a:t>Chunking Strategy</a:t>
+            </a:r>
+            <a:endParaRPr lang="nl-NL" sz="1000" b="1" dirty="0" err="1">
+              <a:solidFill>
+                <a:prstClr val="black"/>
+              </a:solidFill>
+              <a:latin typeface="Verdana" panose="020B0604030504040204" pitchFamily="34" charset="0"/>
+              <a:ea typeface="Verdana" panose="020B0604030504040204" pitchFamily="34" charset="0"/>
+            </a:endParaRPr>
+          </a:p>
+        </p:txBody>
+      </p:sp>
+      <p:pic>
+        <p:nvPicPr>
+          <p:cNvPr id="6" name="Picture 5">
+            <a:extLst>
+              <a:ext uri="{FF2B5EF4-FFF2-40B4-BE49-F238E27FC236}">
+                <a16:creationId xmlns:a16="http://schemas.microsoft.com/office/drawing/2014/main" id="{C48F68A5-2C15-5324-6EFE-EEFC6ECF31EC}"/>
+              </a:ext>
+            </a:extLst>
+          </p:cNvPr>
+          <p:cNvPicPr>
+            <a:picLocks noChangeAspect="1"/>
+          </p:cNvPicPr>
+          <p:nvPr/>
+        </p:nvPicPr>
+        <p:blipFill>
+          <a:blip r:embed="rId8">
+            <a:clrChange>
+              <a:clrFrom>
+                <a:srgbClr val="F4F4F6"/>
+              </a:clrFrom>
+              <a:clrTo>
+                <a:srgbClr val="F4F4F6">
+                  <a:alpha val="0"/>
+                </a:srgbClr>
+              </a:clrTo>
+            </a:clrChange>
+          </a:blip>
+          <a:stretch>
+            <a:fillRect/>
+          </a:stretch>
+        </p:blipFill>
+        <p:spPr>
+          <a:xfrm>
+            <a:off x="1337751" y="3421219"/>
+            <a:ext cx="613721" cy="650917"/>
+          </a:xfrm>
+          <a:prstGeom prst="rect">
+            <a:avLst/>
+          </a:prstGeom>
+        </p:spPr>
+      </p:pic>
+      <p:sp>
+        <p:nvSpPr>
+          <p:cNvPr id="7" name="TextBox 6">
+            <a:extLst>
+              <a:ext uri="{FF2B5EF4-FFF2-40B4-BE49-F238E27FC236}">
+                <a16:creationId xmlns:a16="http://schemas.microsoft.com/office/drawing/2014/main" id="{D03CE48F-D58E-65A9-BA6C-B5137CD1971C}"/>
+              </a:ext>
+            </a:extLst>
+          </p:cNvPr>
+          <p:cNvSpPr txBox="1"/>
+          <p:nvPr/>
+        </p:nvSpPr>
+        <p:spPr>
+          <a:xfrm>
+            <a:off x="1233500" y="3118647"/>
+            <a:ext cx="856325" cy="252120"/>
+          </a:xfrm>
+          <a:prstGeom prst="rect">
+            <a:avLst/>
+          </a:prstGeom>
+          <a:noFill/>
+        </p:spPr>
+        <p:txBody>
+          <a:bodyPr wrap="none" rtlCol="0">
+            <a:spAutoFit/>
+          </a:bodyPr>
+          <a:lstStyle/>
+          <a:p>
+            <a:pPr marL="0" marR="0" lvl="0" indent="0" defTabSz="914400" eaLnBrk="1" fontAlgn="auto" latinLnBrk="0" hangingPunct="1">
+              <a:lnSpc>
+                <a:spcPct val="150000"/>
+              </a:lnSpc>
+              <a:spcBef>
+                <a:spcPts val="0"/>
+              </a:spcBef>
+              <a:spcAft>
+                <a:spcPts val="0"/>
+              </a:spcAft>
+              <a:buClrTx/>
+              <a:buSzTx/>
+              <a:buFontTx/>
+              <a:buNone/>
+              <a:tabLst/>
+              <a:defRPr/>
+            </a:pPr>
+            <a:r>
+              <a:rPr lang="en-US" sz="800" kern="0" dirty="0">
+                <a:solidFill>
+                  <a:prstClr val="black"/>
+                </a:solidFill>
+                <a:latin typeface="Verdana" panose="020B0604030504040204" pitchFamily="34" charset="0"/>
+                <a:ea typeface="Verdana" panose="020B0604030504040204" pitchFamily="34" charset="0"/>
+              </a:rPr>
+              <a:t>Document(s)</a:t>
+            </a:r>
+            <a:endParaRPr kumimoji="0" lang="nl-NL" sz="800" b="0" i="0" u="none" strike="noStrike" kern="0" cap="none" spc="0" normalizeH="0" baseline="0" noProof="0" dirty="0" err="1">
+              <a:ln>
+                <a:noFill/>
+              </a:ln>
+              <a:solidFill>
+                <a:prstClr val="black"/>
+              </a:solidFill>
+              <a:effectLst/>
+              <a:uLnTx/>
+              <a:uFillTx/>
+              <a:latin typeface="Verdana" panose="020B0604030504040204" pitchFamily="34" charset="0"/>
+              <a:ea typeface="Verdana" panose="020B0604030504040204" pitchFamily="34" charset="0"/>
+            </a:endParaRPr>
+          </a:p>
+        </p:txBody>
+      </p:sp>
+      <p:cxnSp>
+        <p:nvCxnSpPr>
+          <p:cNvPr id="10" name="Straight Arrow Connector 9">
+            <a:extLst>
+              <a:ext uri="{FF2B5EF4-FFF2-40B4-BE49-F238E27FC236}">
+                <a16:creationId xmlns:a16="http://schemas.microsoft.com/office/drawing/2014/main" id="{1C938317-D636-242E-0273-A948D86864E5}"/>
+              </a:ext>
+            </a:extLst>
+          </p:cNvPr>
+          <p:cNvCxnSpPr>
+            <a:cxnSpLocks/>
+          </p:cNvCxnSpPr>
+          <p:nvPr/>
+        </p:nvCxnSpPr>
+        <p:spPr>
+          <a:xfrm flipH="1">
+            <a:off x="4294437" y="1906698"/>
+            <a:ext cx="180000" cy="0"/>
+          </a:xfrm>
+          <a:prstGeom prst="straightConnector1">
+            <a:avLst/>
+          </a:prstGeom>
+          <a:ln w="19050" cap="flat" cmpd="sng" algn="ctr">
+            <a:solidFill>
+              <a:schemeClr val="accent3"/>
+            </a:solidFill>
+            <a:prstDash val="solid"/>
+            <a:round/>
+            <a:headEnd type="none" w="med" len="med"/>
+            <a:tailEnd type="arrow" w="med" len="med"/>
+          </a:ln>
+        </p:spPr>
+        <p:style>
+          <a:lnRef idx="0">
+            <a:scrgbClr r="0" g="0" b="0"/>
+          </a:lnRef>
+          <a:fillRef idx="0">
+            <a:scrgbClr r="0" g="0" b="0"/>
+          </a:fillRef>
+          <a:effectRef idx="0">
+            <a:scrgbClr r="0" g="0" b="0"/>
+          </a:effectRef>
+          <a:fontRef idx="minor">
+            <a:schemeClr val="tx1"/>
+          </a:fontRef>
+        </p:style>
+      </p:cxnSp>
+      <p:pic>
+        <p:nvPicPr>
+          <p:cNvPr id="30" name="Picture 2" descr="Bot (informática) - EcuRed">
+            <a:extLst>
+              <a:ext uri="{FF2B5EF4-FFF2-40B4-BE49-F238E27FC236}">
+                <a16:creationId xmlns:a16="http://schemas.microsoft.com/office/drawing/2014/main" id="{ECC3BD2E-355D-70C9-77FB-3613C260972D}"/>
+              </a:ext>
+            </a:extLst>
+          </p:cNvPr>
+          <p:cNvPicPr>
+            <a:picLocks noChangeAspect="1" noChangeArrowheads="1"/>
+          </p:cNvPicPr>
+          <p:nvPr/>
+        </p:nvPicPr>
+        <p:blipFill rotWithShape="1">
+          <a:blip r:embed="rId3">
+            <a:clrChange>
+              <a:clrFrom>
+                <a:srgbClr val="FFFFFF"/>
+              </a:clrFrom>
+              <a:clrTo>
+                <a:srgbClr val="FFFFFF">
+                  <a:alpha val="0"/>
+                </a:srgbClr>
+              </a:clrTo>
+            </a:clrChange>
+            <a:duotone>
+              <a:schemeClr val="accent2">
+                <a:shade val="45000"/>
+                <a:satMod val="135000"/>
+              </a:schemeClr>
+              <a:prstClr val="white"/>
+            </a:duotone>
+            <a:extLst>
+              <a:ext uri="{28A0092B-C50C-407E-A947-70E740481C1C}">
+                <a14:useLocalDpi xmlns:a14="http://schemas.microsoft.com/office/drawing/2010/main" val="0"/>
+              </a:ext>
+            </a:extLst>
+          </a:blip>
+          <a:srcRect l="18962" t="6530" r="16637" b="12432"/>
+          <a:stretch/>
+        </p:blipFill>
+        <p:spPr bwMode="auto">
+          <a:xfrm>
+            <a:off x="3962281" y="1840836"/>
+            <a:ext cx="269049" cy="338554"/>
+          </a:xfrm>
+          <a:prstGeom prst="rect">
+            <a:avLst/>
+          </a:prstGeom>
+          <a:noFill/>
+          <a:extLst>
+            <a:ext uri="{909E8E84-426E-40DD-AFC4-6F175D3DCCD1}">
+              <a14:hiddenFill xmlns:a14="http://schemas.microsoft.com/office/drawing/2010/main">
+                <a:solidFill>
+                  <a:srgbClr val="FFFFFF"/>
+                </a:solidFill>
+              </a14:hiddenFill>
+            </a:ext>
+          </a:extLst>
+        </p:spPr>
+      </p:pic>
+    </p:spTree>
+    <p:extLst>
+      <p:ext uri="{BB962C8B-B14F-4D97-AF65-F5344CB8AC3E}">
+        <p14:creationId xmlns:p14="http://schemas.microsoft.com/office/powerpoint/2010/main" val="683859720"/>
+      </p:ext>
+    </p:extLst>
+  </p:cSld>
+  <p:clrMapOvr>
+    <a:masterClrMapping/>
+  </p:clrMapOvr>
+</p:sld>
+</file>
+
 <file path=ppt/theme/theme1.xml><?xml version="1.0" encoding="utf-8"?>
 <a:theme xmlns:a="http://schemas.openxmlformats.org/drawingml/2006/main" name="Office Theme">
   <a:themeElements>

</xml_diff>